<commit_message>
Fix overflowing PowerShell line in figure 11; keep user's title-slide edits
Co-Authored-By: Claude Opus 5.5 <noreply@anthropic.com>
Claude-Session: https://claude.ai/code/session_01Fr4pnoBCRDUCtsUaoRy2sX
</commit_message>
<xml_diff>
--- a/Incident_Monitoring_Presentation.pptx
+++ b/Incident_Monitoring_Presentation.pptx
@@ -5,26 +5,26 @@
     <p:sldMasterId id="2147483648" r:id="rId1"/>
   </p:sldMasterIdLst>
   <p:sldIdLst>
-    <p:sldId id="256" r:id="rId7"/>
-    <p:sldId id="257" r:id="rId8"/>
-    <p:sldId id="258" r:id="rId9"/>
-    <p:sldId id="259" r:id="rId10"/>
-    <p:sldId id="260" r:id="rId11"/>
-    <p:sldId id="261" r:id="rId12"/>
-    <p:sldId id="262" r:id="rId13"/>
-    <p:sldId id="263" r:id="rId14"/>
-    <p:sldId id="264" r:id="rId15"/>
-    <p:sldId id="265" r:id="rId16"/>
-    <p:sldId id="266" r:id="rId17"/>
-    <p:sldId id="267" r:id="rId18"/>
-    <p:sldId id="268" r:id="rId19"/>
-    <p:sldId id="269" r:id="rId20"/>
-    <p:sldId id="270" r:id="rId21"/>
-    <p:sldId id="271" r:id="rId22"/>
-    <p:sldId id="272" r:id="rId23"/>
-    <p:sldId id="273" r:id="rId24"/>
+    <p:sldId id="256" r:id="rId2"/>
+    <p:sldId id="257" r:id="rId3"/>
+    <p:sldId id="258" r:id="rId4"/>
+    <p:sldId id="259" r:id="rId5"/>
+    <p:sldId id="260" r:id="rId6"/>
+    <p:sldId id="261" r:id="rId7"/>
+    <p:sldId id="262" r:id="rId8"/>
+    <p:sldId id="263" r:id="rId9"/>
+    <p:sldId id="264" r:id="rId10"/>
+    <p:sldId id="265" r:id="rId11"/>
+    <p:sldId id="266" r:id="rId12"/>
+    <p:sldId id="267" r:id="rId13"/>
+    <p:sldId id="268" r:id="rId14"/>
+    <p:sldId id="269" r:id="rId15"/>
+    <p:sldId id="270" r:id="rId16"/>
+    <p:sldId id="271" r:id="rId17"/>
+    <p:sldId id="272" r:id="rId18"/>
+    <p:sldId id="273" r:id="rId19"/>
   </p:sldIdLst>
-  <p:sldSz cx="12191695" cy="6858000" type="screen4x3"/>
+  <p:sldSz cx="12192000" cy="6858000"/>
   <p:notesSz cx="6858000" cy="9144000"/>
   <p:defaultTextStyle>
     <a:defPPr>
@@ -121,6 +121,22 @@
       </a:defRPr>
     </a:lvl9pPr>
   </p:defaultTextStyle>
+  <p:extLst>
+    <p:ext uri="{EFAFB233-063F-42B5-8137-9DF3F51BA10A}">
+      <p15:sldGuideLst xmlns:p15="http://schemas.microsoft.com/office/powerpoint/2012/main">
+        <p15:guide id="1" orient="horz" pos="2160">
+          <p15:clr>
+            <a:srgbClr val="A4A3A4"/>
+          </p15:clr>
+        </p15:guide>
+        <p15:guide id="2" pos="2880">
+          <p15:clr>
+            <a:srgbClr val="A4A3A4"/>
+          </p15:clr>
+        </p15:guide>
+      </p15:sldGuideLst>
+    </p:ext>
+  </p:extLst>
 </p:presentation>
 </file>
 
@@ -305,7 +321,7 @@
           <a:p>
             <a:fld id="{5BCAD085-E8A6-8845-BD4E-CB4CCA059FC4}" type="datetimeFigureOut">
               <a:rPr lang="en-US" smtClean="0"/>
-              <a:t>1/27/13</a:t>
+              <a:t>10/22/2026</a:t>
             </a:fld>
             <a:endParaRPr lang="en-US"/>
           </a:p>
@@ -475,7 +491,7 @@
           <a:p>
             <a:fld id="{5BCAD085-E8A6-8845-BD4E-CB4CCA059FC4}" type="datetimeFigureOut">
               <a:rPr lang="en-US" smtClean="0"/>
-              <a:t>1/27/13</a:t>
+              <a:t>10/22/2026</a:t>
             </a:fld>
             <a:endParaRPr lang="en-US"/>
           </a:p>
@@ -655,7 +671,7 @@
           <a:p>
             <a:fld id="{5BCAD085-E8A6-8845-BD4E-CB4CCA059FC4}" type="datetimeFigureOut">
               <a:rPr lang="en-US" smtClean="0"/>
-              <a:t>1/27/13</a:t>
+              <a:t>10/22/2026</a:t>
             </a:fld>
             <a:endParaRPr lang="en-US"/>
           </a:p>
@@ -825,7 +841,7 @@
           <a:p>
             <a:fld id="{5BCAD085-E8A6-8845-BD4E-CB4CCA059FC4}" type="datetimeFigureOut">
               <a:rPr lang="en-US" smtClean="0"/>
-              <a:t>1/27/13</a:t>
+              <a:t>10/22/2026</a:t>
             </a:fld>
             <a:endParaRPr lang="en-US"/>
           </a:p>
@@ -1071,7 +1087,7 @@
           <a:p>
             <a:fld id="{5BCAD085-E8A6-8845-BD4E-CB4CCA059FC4}" type="datetimeFigureOut">
               <a:rPr lang="en-US" smtClean="0"/>
-              <a:t>1/27/13</a:t>
+              <a:t>10/22/2026</a:t>
             </a:fld>
             <a:endParaRPr lang="en-US"/>
           </a:p>
@@ -1359,7 +1375,7 @@
           <a:p>
             <a:fld id="{5BCAD085-E8A6-8845-BD4E-CB4CCA059FC4}" type="datetimeFigureOut">
               <a:rPr lang="en-US" smtClean="0"/>
-              <a:t>1/27/13</a:t>
+              <a:t>10/22/2026</a:t>
             </a:fld>
             <a:endParaRPr lang="en-US"/>
           </a:p>
@@ -1781,7 +1797,7 @@
           <a:p>
             <a:fld id="{5BCAD085-E8A6-8845-BD4E-CB4CCA059FC4}" type="datetimeFigureOut">
               <a:rPr lang="en-US" smtClean="0"/>
-              <a:t>1/27/13</a:t>
+              <a:t>10/22/2026</a:t>
             </a:fld>
             <a:endParaRPr lang="en-US"/>
           </a:p>
@@ -1899,7 +1915,7 @@
           <a:p>
             <a:fld id="{5BCAD085-E8A6-8845-BD4E-CB4CCA059FC4}" type="datetimeFigureOut">
               <a:rPr lang="en-US" smtClean="0"/>
-              <a:t>1/27/13</a:t>
+              <a:t>10/22/2026</a:t>
             </a:fld>
             <a:endParaRPr lang="en-US"/>
           </a:p>
@@ -1994,7 +2010,7 @@
           <a:p>
             <a:fld id="{5BCAD085-E8A6-8845-BD4E-CB4CCA059FC4}" type="datetimeFigureOut">
               <a:rPr lang="en-US" smtClean="0"/>
-              <a:t>1/27/13</a:t>
+              <a:t>10/22/2026</a:t>
             </a:fld>
             <a:endParaRPr lang="en-US"/>
           </a:p>
@@ -2271,7 +2287,7 @@
           <a:p>
             <a:fld id="{5BCAD085-E8A6-8845-BD4E-CB4CCA059FC4}" type="datetimeFigureOut">
               <a:rPr lang="en-US" smtClean="0"/>
-              <a:t>1/27/13</a:t>
+              <a:t>10/22/2026</a:t>
             </a:fld>
             <a:endParaRPr lang="en-US"/>
           </a:p>
@@ -2524,7 +2540,7 @@
           <a:p>
             <a:fld id="{5BCAD085-E8A6-8845-BD4E-CB4CCA059FC4}" type="datetimeFigureOut">
               <a:rPr lang="en-US" smtClean="0"/>
-              <a:t>1/27/13</a:t>
+              <a:t>10/22/2026</a:t>
             </a:fld>
             <a:endParaRPr lang="en-US"/>
           </a:p>
@@ -2737,7 +2753,7 @@
           <a:p>
             <a:fld id="{5BCAD085-E8A6-8845-BD4E-CB4CCA059FC4}" type="datetimeFigureOut">
               <a:rPr lang="en-US" smtClean="0"/>
-              <a:t>1/27/13</a:t>
+              <a:t>10/22/2026</a:t>
             </a:fld>
             <a:endParaRPr lang="en-US"/>
           </a:p>
@@ -3096,7 +3112,7 @@
 </file>
 
 <file path=ppt/slides/slide1.xml><?xml version="1.0" encoding="utf-8"?>
-<p:sld xmlns:a="http://schemas.openxmlformats.org/drawingml/2006/main" xmlns:p="http://schemas.openxmlformats.org/presentationml/2006/main" xmlns:r="http://schemas.openxmlformats.org/officeDocument/2006/relationships">
+<p:sld xmlns:a="http://schemas.openxmlformats.org/drawingml/2006/main" xmlns:r="http://schemas.openxmlformats.org/officeDocument/2006/relationships" xmlns:p="http://schemas.openxmlformats.org/presentationml/2006/main">
   <p:cSld>
     <p:spTree>
       <p:nvGrpSpPr>
@@ -3104,7 +3120,14 @@
         <p:cNvGrpSpPr/>
         <p:nvPr/>
       </p:nvGrpSpPr>
-      <p:grpSpPr/>
+      <p:grpSpPr>
+        <a:xfrm>
+          <a:off x="0" y="0"/>
+          <a:ext cx="0" cy="0"/>
+          <a:chOff x="0" y="0"/>
+          <a:chExt cx="0" cy="0"/>
+        </a:xfrm>
+      </p:grpSpPr>
       <p:sp>
         <p:nvSpPr>
           <p:cNvPr id="2" name="Rectangle 1"/>
@@ -3146,6 +3169,7 @@
           <a:lstStyle/>
           <a:p>
             <a:pPr algn="ctr"/>
+            <a:endParaRPr/>
           </a:p>
         </p:txBody>
       </p:sp>
@@ -3190,6 +3214,7 @@
           <a:lstStyle/>
           <a:p>
             <a:pPr algn="ctr"/>
+            <a:endParaRPr/>
           </a:p>
         </p:txBody>
       </p:sp>
@@ -3210,7 +3235,7 @@
           <a:noFill/>
         </p:spPr>
         <p:txBody>
-          <a:bodyPr wrap="square" anchor="t" lIns="45720" rIns="45720" tIns="27432" bIns="27432">
+          <a:bodyPr wrap="square" lIns="45720" tIns="27432" rIns="45720" bIns="27432" anchor="t">
             <a:spAutoFit/>
           </a:bodyPr>
           <a:lstStyle/>
@@ -3249,7 +3274,7 @@
           <a:noFill/>
         </p:spPr>
         <p:txBody>
-          <a:bodyPr wrap="square" anchor="t" lIns="45720" rIns="45720" tIns="27432" bIns="27432">
+          <a:bodyPr wrap="square" lIns="45720" tIns="27432" rIns="45720" bIns="27432" anchor="t">
             <a:spAutoFit/>
           </a:bodyPr>
           <a:lstStyle/>
@@ -3288,7 +3313,7 @@
           <a:noFill/>
         </p:spPr>
         <p:txBody>
-          <a:bodyPr wrap="square" anchor="t" lIns="45720" rIns="45720" tIns="27432" bIns="27432">
+          <a:bodyPr wrap="square" lIns="45720" tIns="27432" rIns="45720" bIns="27432" anchor="t">
             <a:spAutoFit/>
           </a:bodyPr>
           <a:lstStyle/>
@@ -3319,7 +3344,7 @@
         <p:spPr>
           <a:xfrm>
             <a:off x="731520" y="5029200"/>
-            <a:ext cx="7315200" cy="1097280"/>
+            <a:ext cx="7315200" cy="597087"/>
           </a:xfrm>
           <a:prstGeom prst="rect">
             <a:avLst/>
@@ -3327,7 +3352,7 @@
           <a:noFill/>
         </p:spPr>
         <p:txBody>
-          <a:bodyPr wrap="square" anchor="t" lIns="45720" rIns="45720" tIns="27432" bIns="27432">
+          <a:bodyPr wrap="square" lIns="45720" tIns="27432" rIns="45720" bIns="27432" anchor="t">
             <a:spAutoFit/>
           </a:bodyPr>
           <a:lstStyle/>
@@ -3338,59 +3363,101 @@
               </a:lnSpc>
             </a:pPr>
             <a:r>
-              <a:rPr sz="1600" b="0" i="0">
+              <a:rPr sz="1600" b="0" i="0" dirty="0" err="1">
                 <a:solidFill>
                   <a:srgbClr val="C9D6E8"/>
                 </a:solidFill>
                 <a:latin typeface="Calibri"/>
               </a:rPr>
-              <a:t>Выполнил: </a:t>
-            </a:r>
-            <a:r>
-              <a:rPr sz="1600" b="0" i="0">
+              <a:t>Выполнил</a:t>
+            </a:r>
+            <a:r>
+              <a:rPr sz="1600" b="0" i="0" dirty="0">
+                <a:solidFill>
+                  <a:srgbClr val="C9D6E8"/>
+                </a:solidFill>
+                <a:latin typeface="Calibri"/>
+              </a:rPr>
+              <a:t>: </a:t>
+            </a:r>
+            <a:r>
+              <a:rPr lang="ru-RU" sz="1600" dirty="0" smtClean="0">
+                <a:solidFill>
+                  <a:srgbClr val="C9D6E8"/>
+                </a:solidFill>
+                <a:latin typeface="Calibri"/>
+              </a:rPr>
+              <a:t>Козырев Дмитрий Александрович</a:t>
+            </a:r>
+            <a:endParaRPr sz="1600" b="0" i="0" dirty="0">
+              <a:solidFill>
+                <a:srgbClr val="FFFFFF"/>
+              </a:solidFill>
+              <a:latin typeface="Calibri"/>
+            </a:endParaRPr>
+          </a:p>
+          <a:p>
+            <a:pPr algn="l">
+              <a:lnSpc>
+                <a:spcPct val="110000"/>
+              </a:lnSpc>
+            </a:pPr>
+            <a:r>
+              <a:rPr sz="1600" b="0" i="0" dirty="0" err="1">
+                <a:solidFill>
+                  <a:srgbClr val="C9D6E8"/>
+                </a:solidFill>
+                <a:latin typeface="Calibri"/>
+              </a:rPr>
+              <a:t>Группа</a:t>
+            </a:r>
+            <a:r>
+              <a:rPr sz="1600" b="0" i="0" dirty="0">
+                <a:solidFill>
+                  <a:srgbClr val="C9D6E8"/>
+                </a:solidFill>
+                <a:latin typeface="Calibri"/>
+              </a:rPr>
+              <a:t>: </a:t>
+            </a:r>
+            <a:r>
+              <a:rPr lang="ru-RU" sz="1600" dirty="0" smtClean="0">
                 <a:solidFill>
                   <a:srgbClr val="FFFFFF"/>
                 </a:solidFill>
                 <a:latin typeface="Calibri"/>
               </a:rPr>
-              <a:t>______________________</a:t>
-            </a:r>
-          </a:p>
-          <a:p>
-            <a:pPr algn="l">
-              <a:lnSpc>
-                <a:spcPct val="110000"/>
-              </a:lnSpc>
-            </a:pPr>
-            <a:r>
-              <a:rPr sz="1600" b="0" i="0">
+              <a:t>КБС-801</a:t>
+            </a:r>
+            <a:r>
+              <a:rPr sz="1600" b="0" i="0" dirty="0" smtClean="0">
                 <a:solidFill>
                   <a:srgbClr val="C9D6E8"/>
                 </a:solidFill>
                 <a:latin typeface="Calibri"/>
               </a:rPr>
-              <a:t>Группа: </a:t>
-            </a:r>
-            <a:r>
-              <a:rPr sz="1600" b="0" i="0">
-                <a:solidFill>
-                  <a:srgbClr val="FFFFFF"/>
-                </a:solidFill>
-                <a:latin typeface="Calibri"/>
-              </a:rPr>
-              <a:t>________</a:t>
-            </a:r>
-            <a:r>
-              <a:rPr sz="1600" b="0" i="0">
+              <a:t>      </a:t>
+            </a:r>
+            <a:r>
+              <a:rPr sz="1600" b="0" i="0" dirty="0" err="1">
                 <a:solidFill>
                   <a:srgbClr val="C9D6E8"/>
                 </a:solidFill>
                 <a:latin typeface="Calibri"/>
               </a:rPr>
-              <a:t>      Дата: </a:t>
-            </a:r>
-            <a:r>
-              <a:rPr sz="1600" b="0" i="0">
+              <a:t>Дата</a:t>
+            </a:r>
+            <a:r>
+              <a:rPr sz="1600" b="0" i="0" dirty="0">
+                <a:solidFill>
+                  <a:srgbClr val="C9D6E8"/>
+                </a:solidFill>
+                <a:latin typeface="Calibri"/>
+              </a:rPr>
+              <a:t>: </a:t>
+            </a:r>
+            <a:r>
+              <a:rPr sz="1600" b="0" i="0" dirty="0">
                 <a:solidFill>
                   <a:srgbClr val="FFFFFF"/>
                 </a:solidFill>
@@ -3410,7 +3477,7 @@
 </file>
 
 <file path=ppt/slides/slide10.xml><?xml version="1.0" encoding="utf-8"?>
-<p:sld xmlns:a="http://schemas.openxmlformats.org/drawingml/2006/main" xmlns:p="http://schemas.openxmlformats.org/presentationml/2006/main" xmlns:r="http://schemas.openxmlformats.org/officeDocument/2006/relationships">
+<p:sld xmlns:a="http://schemas.openxmlformats.org/drawingml/2006/main" xmlns:r="http://schemas.openxmlformats.org/officeDocument/2006/relationships" xmlns:p="http://schemas.openxmlformats.org/presentationml/2006/main">
   <p:cSld>
     <p:spTree>
       <p:nvGrpSpPr>
@@ -3418,7 +3485,14 @@
         <p:cNvGrpSpPr/>
         <p:nvPr/>
       </p:nvGrpSpPr>
-      <p:grpSpPr/>
+      <p:grpSpPr>
+        <a:xfrm>
+          <a:off x="0" y="0"/>
+          <a:ext cx="0" cy="0"/>
+          <a:chOff x="0" y="0"/>
+          <a:chExt cx="0" cy="0"/>
+        </a:xfrm>
+      </p:grpSpPr>
       <p:sp>
         <p:nvSpPr>
           <p:cNvPr id="2" name="Rectangle 1"/>
@@ -3460,6 +3534,7 @@
           <a:lstStyle/>
           <a:p>
             <a:pPr algn="ctr"/>
+            <a:endParaRPr/>
           </a:p>
         </p:txBody>
       </p:sp>
@@ -3504,6 +3579,7 @@
           <a:lstStyle/>
           <a:p>
             <a:pPr algn="ctr"/>
+            <a:endParaRPr/>
           </a:p>
         </p:txBody>
       </p:sp>
@@ -3550,6 +3626,7 @@
           <a:lstStyle/>
           <a:p>
             <a:pPr algn="ctr"/>
+            <a:endParaRPr/>
           </a:p>
         </p:txBody>
       </p:sp>
@@ -3570,7 +3647,7 @@
           <a:noFill/>
         </p:spPr>
         <p:txBody>
-          <a:bodyPr wrap="square" anchor="ctr" lIns="45720" rIns="45720" tIns="27432" bIns="27432">
+          <a:bodyPr wrap="square" lIns="45720" tIns="27432" rIns="45720" bIns="27432" anchor="ctr">
             <a:spAutoFit/>
           </a:bodyPr>
           <a:lstStyle/>
@@ -3609,7 +3686,7 @@
           <a:noFill/>
         </p:spPr>
         <p:txBody>
-          <a:bodyPr wrap="square" anchor="ctr" lIns="45720" rIns="45720" tIns="27432" bIns="27432">
+          <a:bodyPr wrap="square" lIns="45720" tIns="27432" rIns="45720" bIns="27432" anchor="ctr">
             <a:spAutoFit/>
           </a:bodyPr>
           <a:lstStyle/>
@@ -3696,6 +3773,7 @@
           <a:lstStyle/>
           <a:p>
             <a:pPr algn="ctr"/>
+            <a:endParaRPr/>
           </a:p>
         </p:txBody>
       </p:sp>
@@ -3716,7 +3794,7 @@
           <a:noFill/>
         </p:spPr>
         <p:txBody>
-          <a:bodyPr wrap="square" anchor="t" lIns="45720" rIns="45720" tIns="27432" bIns="27432">
+          <a:bodyPr wrap="square" lIns="45720" tIns="27432" rIns="45720" bIns="27432" anchor="t">
             <a:spAutoFit/>
           </a:bodyPr>
           <a:lstStyle/>
@@ -3779,6 +3857,7 @@
           <a:lstStyle/>
           <a:p>
             <a:pPr algn="ctr"/>
+            <a:endParaRPr/>
           </a:p>
         </p:txBody>
       </p:sp>
@@ -3823,6 +3902,7 @@
           <a:lstStyle/>
           <a:p>
             <a:pPr algn="ctr"/>
+            <a:endParaRPr/>
           </a:p>
         </p:txBody>
       </p:sp>
@@ -3843,7 +3923,7 @@
           <a:noFill/>
         </p:spPr>
         <p:txBody>
-          <a:bodyPr wrap="square" anchor="t" lIns="45720" rIns="45720" tIns="27432" bIns="27432">
+          <a:bodyPr wrap="square" lIns="45720" tIns="27432" rIns="45720" bIns="27432" anchor="t">
             <a:spAutoFit/>
           </a:bodyPr>
           <a:lstStyle/>
@@ -3882,7 +3962,7 @@
           <a:noFill/>
         </p:spPr>
         <p:txBody>
-          <a:bodyPr wrap="square" anchor="t" lIns="45720" rIns="45720" tIns="27432" bIns="27432">
+          <a:bodyPr wrap="square" lIns="45720" tIns="27432" rIns="45720" bIns="27432" anchor="t">
             <a:spAutoFit/>
           </a:bodyPr>
           <a:lstStyle/>
@@ -4040,6 +4120,7 @@
           <a:lstStyle/>
           <a:p>
             <a:pPr algn="ctr"/>
+            <a:endParaRPr/>
           </a:p>
         </p:txBody>
       </p:sp>
@@ -4060,7 +4141,7 @@
           <a:noFill/>
         </p:spPr>
         <p:txBody>
-          <a:bodyPr wrap="square" anchor="t" lIns="45720" rIns="45720" tIns="27432" bIns="27432">
+          <a:bodyPr wrap="square" lIns="45720" tIns="27432" rIns="45720" bIns="27432" anchor="t">
             <a:spAutoFit/>
           </a:bodyPr>
           <a:lstStyle/>
@@ -4195,7 +4276,7 @@
           <a:noFill/>
         </p:spPr>
         <p:txBody>
-          <a:bodyPr wrap="square" anchor="t" lIns="45720" rIns="45720" tIns="27432" bIns="27432">
+          <a:bodyPr wrap="square" lIns="45720" tIns="27432" rIns="45720" bIns="27432" anchor="t">
             <a:spAutoFit/>
           </a:bodyPr>
           <a:lstStyle/>
@@ -4234,7 +4315,7 @@
           <a:noFill/>
         </p:spPr>
         <p:txBody>
-          <a:bodyPr wrap="square" anchor="t" lIns="45720" rIns="45720" tIns="27432" bIns="27432">
+          <a:bodyPr wrap="square" lIns="45720" tIns="27432" rIns="45720" bIns="27432" anchor="t">
             <a:spAutoFit/>
           </a:bodyPr>
           <a:lstStyle/>
@@ -4265,7 +4346,7 @@
 </file>
 
 <file path=ppt/slides/slide11.xml><?xml version="1.0" encoding="utf-8"?>
-<p:sld xmlns:a="http://schemas.openxmlformats.org/drawingml/2006/main" xmlns:p="http://schemas.openxmlformats.org/presentationml/2006/main" xmlns:r="http://schemas.openxmlformats.org/officeDocument/2006/relationships">
+<p:sld xmlns:a="http://schemas.openxmlformats.org/drawingml/2006/main" xmlns:r="http://schemas.openxmlformats.org/officeDocument/2006/relationships" xmlns:p="http://schemas.openxmlformats.org/presentationml/2006/main">
   <p:cSld>
     <p:spTree>
       <p:nvGrpSpPr>
@@ -4273,7 +4354,14 @@
         <p:cNvGrpSpPr/>
         <p:nvPr/>
       </p:nvGrpSpPr>
-      <p:grpSpPr/>
+      <p:grpSpPr>
+        <a:xfrm>
+          <a:off x="0" y="0"/>
+          <a:ext cx="0" cy="0"/>
+          <a:chOff x="0" y="0"/>
+          <a:chExt cx="0" cy="0"/>
+        </a:xfrm>
+      </p:grpSpPr>
       <p:sp>
         <p:nvSpPr>
           <p:cNvPr id="2" name="Rectangle 1"/>
@@ -4315,6 +4403,7 @@
           <a:lstStyle/>
           <a:p>
             <a:pPr algn="ctr"/>
+            <a:endParaRPr/>
           </a:p>
         </p:txBody>
       </p:sp>
@@ -4359,6 +4448,7 @@
           <a:lstStyle/>
           <a:p>
             <a:pPr algn="ctr"/>
+            <a:endParaRPr/>
           </a:p>
         </p:txBody>
       </p:sp>
@@ -4405,6 +4495,7 @@
           <a:lstStyle/>
           <a:p>
             <a:pPr algn="ctr"/>
+            <a:endParaRPr/>
           </a:p>
         </p:txBody>
       </p:sp>
@@ -4425,7 +4516,7 @@
           <a:noFill/>
         </p:spPr>
         <p:txBody>
-          <a:bodyPr wrap="square" anchor="ctr" lIns="45720" rIns="45720" tIns="27432" bIns="27432">
+          <a:bodyPr wrap="square" lIns="45720" tIns="27432" rIns="45720" bIns="27432" anchor="ctr">
             <a:spAutoFit/>
           </a:bodyPr>
           <a:lstStyle/>
@@ -4464,7 +4555,7 @@
           <a:noFill/>
         </p:spPr>
         <p:txBody>
-          <a:bodyPr wrap="square" anchor="ctr" lIns="45720" rIns="45720" tIns="27432" bIns="27432">
+          <a:bodyPr wrap="square" lIns="45720" tIns="27432" rIns="45720" bIns="27432" anchor="ctr">
             <a:spAutoFit/>
           </a:bodyPr>
           <a:lstStyle/>
@@ -4551,6 +4642,7 @@
           <a:lstStyle/>
           <a:p>
             <a:pPr algn="ctr"/>
+            <a:endParaRPr/>
           </a:p>
         </p:txBody>
       </p:sp>
@@ -4571,7 +4663,7 @@
           <a:noFill/>
         </p:spPr>
         <p:txBody>
-          <a:bodyPr wrap="square" anchor="t" lIns="45720" rIns="45720" tIns="27432" bIns="27432">
+          <a:bodyPr wrap="square" lIns="45720" tIns="27432" rIns="45720" bIns="27432" anchor="t">
             <a:spAutoFit/>
           </a:bodyPr>
           <a:lstStyle/>
@@ -4634,6 +4726,7 @@
           <a:lstStyle/>
           <a:p>
             <a:pPr algn="ctr"/>
+            <a:endParaRPr/>
           </a:p>
         </p:txBody>
       </p:sp>
@@ -4678,6 +4771,7 @@
           <a:lstStyle/>
           <a:p>
             <a:pPr algn="ctr"/>
+            <a:endParaRPr/>
           </a:p>
         </p:txBody>
       </p:sp>
@@ -4698,7 +4792,7 @@
           <a:noFill/>
         </p:spPr>
         <p:txBody>
-          <a:bodyPr wrap="square" anchor="t" lIns="45720" rIns="45720" tIns="27432" bIns="27432">
+          <a:bodyPr wrap="square" lIns="45720" tIns="27432" rIns="45720" bIns="27432" anchor="t">
             <a:spAutoFit/>
           </a:bodyPr>
           <a:lstStyle/>
@@ -4737,7 +4831,7 @@
           <a:noFill/>
         </p:spPr>
         <p:txBody>
-          <a:bodyPr wrap="square" anchor="t" lIns="45720" rIns="45720" tIns="27432" bIns="27432">
+          <a:bodyPr wrap="square" lIns="45720" tIns="27432" rIns="45720" bIns="27432" anchor="t">
             <a:spAutoFit/>
           </a:bodyPr>
           <a:lstStyle/>
@@ -4909,7 +5003,7 @@
           <a:noFill/>
         </p:spPr>
         <p:txBody>
-          <a:bodyPr wrap="square" anchor="t" lIns="45720" rIns="45720" tIns="27432" bIns="27432">
+          <a:bodyPr wrap="square" lIns="45720" tIns="27432" rIns="45720" bIns="27432" anchor="t">
             <a:spAutoFit/>
           </a:bodyPr>
           <a:lstStyle/>
@@ -4948,7 +5042,7 @@
           <a:noFill/>
         </p:spPr>
         <p:txBody>
-          <a:bodyPr wrap="square" anchor="t" lIns="45720" rIns="45720" tIns="27432" bIns="27432">
+          <a:bodyPr wrap="square" lIns="45720" tIns="27432" rIns="45720" bIns="27432" anchor="t">
             <a:spAutoFit/>
           </a:bodyPr>
           <a:lstStyle/>
@@ -4979,7 +5073,7 @@
 </file>
 
 <file path=ppt/slides/slide12.xml><?xml version="1.0" encoding="utf-8"?>
-<p:sld xmlns:a="http://schemas.openxmlformats.org/drawingml/2006/main" xmlns:p="http://schemas.openxmlformats.org/presentationml/2006/main" xmlns:r="http://schemas.openxmlformats.org/officeDocument/2006/relationships">
+<p:sld xmlns:a="http://schemas.openxmlformats.org/drawingml/2006/main" xmlns:r="http://schemas.openxmlformats.org/officeDocument/2006/relationships" xmlns:p="http://schemas.openxmlformats.org/presentationml/2006/main">
   <p:cSld>
     <p:spTree>
       <p:nvGrpSpPr>
@@ -4987,7 +5081,14 @@
         <p:cNvGrpSpPr/>
         <p:nvPr/>
       </p:nvGrpSpPr>
-      <p:grpSpPr/>
+      <p:grpSpPr>
+        <a:xfrm>
+          <a:off x="0" y="0"/>
+          <a:ext cx="0" cy="0"/>
+          <a:chOff x="0" y="0"/>
+          <a:chExt cx="0" cy="0"/>
+        </a:xfrm>
+      </p:grpSpPr>
       <p:sp>
         <p:nvSpPr>
           <p:cNvPr id="2" name="Rectangle 1"/>
@@ -5029,6 +5130,7 @@
           <a:lstStyle/>
           <a:p>
             <a:pPr algn="ctr"/>
+            <a:endParaRPr/>
           </a:p>
         </p:txBody>
       </p:sp>
@@ -5073,6 +5175,7 @@
           <a:lstStyle/>
           <a:p>
             <a:pPr algn="ctr"/>
+            <a:endParaRPr/>
           </a:p>
         </p:txBody>
       </p:sp>
@@ -5119,6 +5222,7 @@
           <a:lstStyle/>
           <a:p>
             <a:pPr algn="ctr"/>
+            <a:endParaRPr/>
           </a:p>
         </p:txBody>
       </p:sp>
@@ -5139,7 +5243,7 @@
           <a:noFill/>
         </p:spPr>
         <p:txBody>
-          <a:bodyPr wrap="square" anchor="ctr" lIns="45720" rIns="45720" tIns="27432" bIns="27432">
+          <a:bodyPr wrap="square" lIns="45720" tIns="27432" rIns="45720" bIns="27432" anchor="ctr">
             <a:spAutoFit/>
           </a:bodyPr>
           <a:lstStyle/>
@@ -5178,7 +5282,7 @@
           <a:noFill/>
         </p:spPr>
         <p:txBody>
-          <a:bodyPr wrap="square" anchor="ctr" lIns="45720" rIns="45720" tIns="27432" bIns="27432">
+          <a:bodyPr wrap="square" lIns="45720" tIns="27432" rIns="45720" bIns="27432" anchor="ctr">
             <a:spAutoFit/>
           </a:bodyPr>
           <a:lstStyle/>
@@ -5265,6 +5369,7 @@
           <a:lstStyle/>
           <a:p>
             <a:pPr algn="ctr"/>
+            <a:endParaRPr/>
           </a:p>
         </p:txBody>
       </p:sp>
@@ -5285,7 +5390,7 @@
           <a:noFill/>
         </p:spPr>
         <p:txBody>
-          <a:bodyPr wrap="square" anchor="t" lIns="45720" rIns="45720" tIns="27432" bIns="27432">
+          <a:bodyPr wrap="square" lIns="45720" tIns="27432" rIns="45720" bIns="27432" anchor="t">
             <a:spAutoFit/>
           </a:bodyPr>
           <a:lstStyle/>
@@ -5348,6 +5453,7 @@
           <a:lstStyle/>
           <a:p>
             <a:pPr algn="ctr"/>
+            <a:endParaRPr/>
           </a:p>
         </p:txBody>
       </p:sp>
@@ -5392,6 +5498,7 @@
           <a:lstStyle/>
           <a:p>
             <a:pPr algn="ctr"/>
+            <a:endParaRPr/>
           </a:p>
         </p:txBody>
       </p:sp>
@@ -5412,7 +5519,7 @@
           <a:noFill/>
         </p:spPr>
         <p:txBody>
-          <a:bodyPr wrap="square" anchor="t" lIns="45720" rIns="45720" tIns="27432" bIns="27432">
+          <a:bodyPr wrap="square" lIns="45720" tIns="27432" rIns="45720" bIns="27432" anchor="t">
             <a:spAutoFit/>
           </a:bodyPr>
           <a:lstStyle/>
@@ -5451,7 +5558,7 @@
           <a:noFill/>
         </p:spPr>
         <p:txBody>
-          <a:bodyPr wrap="square" anchor="t" lIns="45720" rIns="45720" tIns="27432" bIns="27432">
+          <a:bodyPr wrap="square" lIns="45720" tIns="27432" rIns="45720" bIns="27432" anchor="t">
             <a:spAutoFit/>
           </a:bodyPr>
           <a:lstStyle/>
@@ -5687,7 +5794,7 @@
           <a:noFill/>
         </p:spPr>
         <p:txBody>
-          <a:bodyPr wrap="square" anchor="t" lIns="45720" rIns="45720" tIns="27432" bIns="27432">
+          <a:bodyPr wrap="square" lIns="45720" tIns="27432" rIns="45720" bIns="27432" anchor="t">
             <a:spAutoFit/>
           </a:bodyPr>
           <a:lstStyle/>
@@ -5726,7 +5833,7 @@
           <a:noFill/>
         </p:spPr>
         <p:txBody>
-          <a:bodyPr wrap="square" anchor="t" lIns="45720" rIns="45720" tIns="27432" bIns="27432">
+          <a:bodyPr wrap="square" lIns="45720" tIns="27432" rIns="45720" bIns="27432" anchor="t">
             <a:spAutoFit/>
           </a:bodyPr>
           <a:lstStyle/>
@@ -5757,7 +5864,7 @@
 </file>
 
 <file path=ppt/slides/slide13.xml><?xml version="1.0" encoding="utf-8"?>
-<p:sld xmlns:a="http://schemas.openxmlformats.org/drawingml/2006/main" xmlns:p="http://schemas.openxmlformats.org/presentationml/2006/main" xmlns:r="http://schemas.openxmlformats.org/officeDocument/2006/relationships">
+<p:sld xmlns:a="http://schemas.openxmlformats.org/drawingml/2006/main" xmlns:r="http://schemas.openxmlformats.org/officeDocument/2006/relationships" xmlns:p="http://schemas.openxmlformats.org/presentationml/2006/main">
   <p:cSld>
     <p:spTree>
       <p:nvGrpSpPr>
@@ -5765,7 +5872,14 @@
         <p:cNvGrpSpPr/>
         <p:nvPr/>
       </p:nvGrpSpPr>
-      <p:grpSpPr/>
+      <p:grpSpPr>
+        <a:xfrm>
+          <a:off x="0" y="0"/>
+          <a:ext cx="0" cy="0"/>
+          <a:chOff x="0" y="0"/>
+          <a:chExt cx="0" cy="0"/>
+        </a:xfrm>
+      </p:grpSpPr>
       <p:sp>
         <p:nvSpPr>
           <p:cNvPr id="2" name="Rectangle 1"/>
@@ -5807,6 +5921,7 @@
           <a:lstStyle/>
           <a:p>
             <a:pPr algn="ctr"/>
+            <a:endParaRPr/>
           </a:p>
         </p:txBody>
       </p:sp>
@@ -5851,6 +5966,7 @@
           <a:lstStyle/>
           <a:p>
             <a:pPr algn="ctr"/>
+            <a:endParaRPr/>
           </a:p>
         </p:txBody>
       </p:sp>
@@ -5897,6 +6013,7 @@
           <a:lstStyle/>
           <a:p>
             <a:pPr algn="ctr"/>
+            <a:endParaRPr/>
           </a:p>
         </p:txBody>
       </p:sp>
@@ -5917,7 +6034,7 @@
           <a:noFill/>
         </p:spPr>
         <p:txBody>
-          <a:bodyPr wrap="square" anchor="ctr" lIns="45720" rIns="45720" tIns="27432" bIns="27432">
+          <a:bodyPr wrap="square" lIns="45720" tIns="27432" rIns="45720" bIns="27432" anchor="ctr">
             <a:spAutoFit/>
           </a:bodyPr>
           <a:lstStyle/>
@@ -5956,7 +6073,7 @@
           <a:noFill/>
         </p:spPr>
         <p:txBody>
-          <a:bodyPr wrap="square" anchor="ctr" lIns="45720" rIns="45720" tIns="27432" bIns="27432">
+          <a:bodyPr wrap="square" lIns="45720" tIns="27432" rIns="45720" bIns="27432" anchor="ctr">
             <a:spAutoFit/>
           </a:bodyPr>
           <a:lstStyle/>
@@ -6043,6 +6160,7 @@
           <a:lstStyle/>
           <a:p>
             <a:pPr algn="ctr"/>
+            <a:endParaRPr/>
           </a:p>
         </p:txBody>
       </p:sp>
@@ -6063,7 +6181,7 @@
           <a:noFill/>
         </p:spPr>
         <p:txBody>
-          <a:bodyPr wrap="square" anchor="t" lIns="45720" rIns="45720" tIns="27432" bIns="27432">
+          <a:bodyPr wrap="square" lIns="45720" tIns="27432" rIns="45720" bIns="27432" anchor="t">
             <a:spAutoFit/>
           </a:bodyPr>
           <a:lstStyle/>
@@ -6126,6 +6244,7 @@
           <a:lstStyle/>
           <a:p>
             <a:pPr algn="ctr"/>
+            <a:endParaRPr/>
           </a:p>
         </p:txBody>
       </p:sp>
@@ -6170,6 +6289,7 @@
           <a:lstStyle/>
           <a:p>
             <a:pPr algn="ctr"/>
+            <a:endParaRPr/>
           </a:p>
         </p:txBody>
       </p:sp>
@@ -6190,7 +6310,7 @@
           <a:noFill/>
         </p:spPr>
         <p:txBody>
-          <a:bodyPr wrap="square" anchor="t" lIns="45720" rIns="45720" tIns="27432" bIns="27432">
+          <a:bodyPr wrap="square" lIns="45720" tIns="27432" rIns="45720" bIns="27432" anchor="t">
             <a:spAutoFit/>
           </a:bodyPr>
           <a:lstStyle/>
@@ -6229,7 +6349,7 @@
           <a:noFill/>
         </p:spPr>
         <p:txBody>
-          <a:bodyPr wrap="square" anchor="t" lIns="45720" rIns="45720" tIns="27432" bIns="27432">
+          <a:bodyPr wrap="square" lIns="45720" tIns="27432" rIns="45720" bIns="27432" anchor="t">
             <a:spAutoFit/>
           </a:bodyPr>
           <a:lstStyle/>
@@ -6465,7 +6585,7 @@
           <a:noFill/>
         </p:spPr>
         <p:txBody>
-          <a:bodyPr wrap="square" anchor="t" lIns="45720" rIns="45720" tIns="27432" bIns="27432">
+          <a:bodyPr wrap="square" lIns="45720" tIns="27432" rIns="45720" bIns="27432" anchor="t">
             <a:spAutoFit/>
           </a:bodyPr>
           <a:lstStyle/>
@@ -6504,7 +6624,7 @@
           <a:noFill/>
         </p:spPr>
         <p:txBody>
-          <a:bodyPr wrap="square" anchor="t" lIns="45720" rIns="45720" tIns="27432" bIns="27432">
+          <a:bodyPr wrap="square" lIns="45720" tIns="27432" rIns="45720" bIns="27432" anchor="t">
             <a:spAutoFit/>
           </a:bodyPr>
           <a:lstStyle/>
@@ -6535,7 +6655,7 @@
 </file>
 
 <file path=ppt/slides/slide14.xml><?xml version="1.0" encoding="utf-8"?>
-<p:sld xmlns:a="http://schemas.openxmlformats.org/drawingml/2006/main" xmlns:p="http://schemas.openxmlformats.org/presentationml/2006/main" xmlns:r="http://schemas.openxmlformats.org/officeDocument/2006/relationships">
+<p:sld xmlns:a="http://schemas.openxmlformats.org/drawingml/2006/main" xmlns:r="http://schemas.openxmlformats.org/officeDocument/2006/relationships" xmlns:p="http://schemas.openxmlformats.org/presentationml/2006/main">
   <p:cSld>
     <p:spTree>
       <p:nvGrpSpPr>
@@ -6543,7 +6663,14 @@
         <p:cNvGrpSpPr/>
         <p:nvPr/>
       </p:nvGrpSpPr>
-      <p:grpSpPr/>
+      <p:grpSpPr>
+        <a:xfrm>
+          <a:off x="0" y="0"/>
+          <a:ext cx="0" cy="0"/>
+          <a:chOff x="0" y="0"/>
+          <a:chExt cx="0" cy="0"/>
+        </a:xfrm>
+      </p:grpSpPr>
       <p:sp>
         <p:nvSpPr>
           <p:cNvPr id="2" name="Rectangle 1"/>
@@ -6585,6 +6712,7 @@
           <a:lstStyle/>
           <a:p>
             <a:pPr algn="ctr"/>
+            <a:endParaRPr/>
           </a:p>
         </p:txBody>
       </p:sp>
@@ -6629,6 +6757,7 @@
           <a:lstStyle/>
           <a:p>
             <a:pPr algn="ctr"/>
+            <a:endParaRPr/>
           </a:p>
         </p:txBody>
       </p:sp>
@@ -6675,6 +6804,7 @@
           <a:lstStyle/>
           <a:p>
             <a:pPr algn="ctr"/>
+            <a:endParaRPr/>
           </a:p>
         </p:txBody>
       </p:sp>
@@ -6695,7 +6825,7 @@
           <a:noFill/>
         </p:spPr>
         <p:txBody>
-          <a:bodyPr wrap="square" anchor="ctr" lIns="45720" rIns="45720" tIns="27432" bIns="27432">
+          <a:bodyPr wrap="square" lIns="45720" tIns="27432" rIns="45720" bIns="27432" anchor="ctr">
             <a:spAutoFit/>
           </a:bodyPr>
           <a:lstStyle/>
@@ -6734,7 +6864,7 @@
           <a:noFill/>
         </p:spPr>
         <p:txBody>
-          <a:bodyPr wrap="square" anchor="ctr" lIns="45720" rIns="45720" tIns="27432" bIns="27432">
+          <a:bodyPr wrap="square" lIns="45720" tIns="27432" rIns="45720" bIns="27432" anchor="ctr">
             <a:spAutoFit/>
           </a:bodyPr>
           <a:lstStyle/>
@@ -6764,16 +6894,15 @@
           </p:cNvPicPr>
           <p:nvPr/>
         </p:nvPicPr>
-        <p:blipFill>
+        <p:blipFill rotWithShape="1">
           <a:blip r:embed="rId2"/>
-          <a:stretch>
-            <a:fillRect/>
-          </a:stretch>
+          <a:srcRect l="-90" b="4917"/>
+          <a:stretch/>
         </p:blipFill>
         <p:spPr>
           <a:xfrm>
-            <a:off x="411480" y="1188720"/>
-            <a:ext cx="7772400" cy="4371975"/>
+            <a:off x="404446" y="1188720"/>
+            <a:ext cx="7779434" cy="4157003"/>
           </a:xfrm>
           <a:prstGeom prst="rect">
             <a:avLst/>
@@ -6821,6 +6950,7 @@
           <a:lstStyle/>
           <a:p>
             <a:pPr algn="ctr"/>
+            <a:endParaRPr/>
           </a:p>
         </p:txBody>
       </p:sp>
@@ -6832,7 +6962,7 @@
         </p:nvSpPr>
         <p:spPr>
           <a:xfrm>
-            <a:off x="411480" y="5597271"/>
+            <a:off x="404446" y="5345723"/>
             <a:ext cx="7772400" cy="274320"/>
           </a:xfrm>
           <a:prstGeom prst="rect">
@@ -6841,7 +6971,7 @@
           <a:noFill/>
         </p:spPr>
         <p:txBody>
-          <a:bodyPr wrap="square" anchor="t" lIns="45720" rIns="45720" tIns="27432" bIns="27432">
+          <a:bodyPr wrap="square" lIns="45720" tIns="27432" rIns="45720" bIns="27432" anchor="t">
             <a:spAutoFit/>
           </a:bodyPr>
           <a:lstStyle/>
@@ -6904,6 +7034,7 @@
           <a:lstStyle/>
           <a:p>
             <a:pPr algn="ctr"/>
+            <a:endParaRPr/>
           </a:p>
         </p:txBody>
       </p:sp>
@@ -6948,6 +7079,7 @@
           <a:lstStyle/>
           <a:p>
             <a:pPr algn="ctr"/>
+            <a:endParaRPr/>
           </a:p>
         </p:txBody>
       </p:sp>
@@ -6968,7 +7100,7 @@
           <a:noFill/>
         </p:spPr>
         <p:txBody>
-          <a:bodyPr wrap="square" anchor="t" lIns="45720" rIns="45720" tIns="27432" bIns="27432">
+          <a:bodyPr wrap="square" lIns="45720" tIns="27432" rIns="45720" bIns="27432" anchor="t">
             <a:spAutoFit/>
           </a:bodyPr>
           <a:lstStyle/>
@@ -7007,7 +7139,7 @@
           <a:noFill/>
         </p:spPr>
         <p:txBody>
-          <a:bodyPr wrap="square" anchor="t" lIns="45720" rIns="45720" tIns="27432" bIns="27432">
+          <a:bodyPr wrap="square" lIns="45720" tIns="27432" rIns="45720" bIns="27432" anchor="t">
             <a:spAutoFit/>
           </a:bodyPr>
           <a:lstStyle/>
@@ -7198,7 +7330,7 @@
           <a:noFill/>
         </p:spPr>
         <p:txBody>
-          <a:bodyPr wrap="square" anchor="t" lIns="45720" rIns="45720" tIns="27432" bIns="27432">
+          <a:bodyPr wrap="square" lIns="45720" tIns="27432" rIns="45720" bIns="27432" anchor="t">
             <a:spAutoFit/>
           </a:bodyPr>
           <a:lstStyle/>
@@ -7237,7 +7369,7 @@
           <a:noFill/>
         </p:spPr>
         <p:txBody>
-          <a:bodyPr wrap="square" anchor="t" lIns="45720" rIns="45720" tIns="27432" bIns="27432">
+          <a:bodyPr wrap="square" lIns="45720" tIns="27432" rIns="45720" bIns="27432" anchor="t">
             <a:spAutoFit/>
           </a:bodyPr>
           <a:lstStyle/>
@@ -7268,7 +7400,7 @@
 </file>
 
 <file path=ppt/slides/slide15.xml><?xml version="1.0" encoding="utf-8"?>
-<p:sld xmlns:a="http://schemas.openxmlformats.org/drawingml/2006/main" xmlns:p="http://schemas.openxmlformats.org/presentationml/2006/main" xmlns:r="http://schemas.openxmlformats.org/officeDocument/2006/relationships">
+<p:sld xmlns:a="http://schemas.openxmlformats.org/drawingml/2006/main" xmlns:r="http://schemas.openxmlformats.org/officeDocument/2006/relationships" xmlns:p="http://schemas.openxmlformats.org/presentationml/2006/main">
   <p:cSld>
     <p:spTree>
       <p:nvGrpSpPr>
@@ -7276,7 +7408,14 @@
         <p:cNvGrpSpPr/>
         <p:nvPr/>
       </p:nvGrpSpPr>
-      <p:grpSpPr/>
+      <p:grpSpPr>
+        <a:xfrm>
+          <a:off x="0" y="0"/>
+          <a:ext cx="0" cy="0"/>
+          <a:chOff x="0" y="0"/>
+          <a:chExt cx="0" cy="0"/>
+        </a:xfrm>
+      </p:grpSpPr>
       <p:sp>
         <p:nvSpPr>
           <p:cNvPr id="2" name="Rectangle 1"/>
@@ -7318,6 +7457,7 @@
           <a:lstStyle/>
           <a:p>
             <a:pPr algn="ctr"/>
+            <a:endParaRPr/>
           </a:p>
         </p:txBody>
       </p:sp>
@@ -7362,6 +7502,7 @@
           <a:lstStyle/>
           <a:p>
             <a:pPr algn="ctr"/>
+            <a:endParaRPr/>
           </a:p>
         </p:txBody>
       </p:sp>
@@ -7408,6 +7549,7 @@
           <a:lstStyle/>
           <a:p>
             <a:pPr algn="ctr"/>
+            <a:endParaRPr/>
           </a:p>
         </p:txBody>
       </p:sp>
@@ -7428,7 +7570,7 @@
           <a:noFill/>
         </p:spPr>
         <p:txBody>
-          <a:bodyPr wrap="square" anchor="ctr" lIns="45720" rIns="45720" tIns="27432" bIns="27432">
+          <a:bodyPr wrap="square" lIns="45720" tIns="27432" rIns="45720" bIns="27432" anchor="ctr">
             <a:spAutoFit/>
           </a:bodyPr>
           <a:lstStyle/>
@@ -7467,7 +7609,7 @@
           <a:noFill/>
         </p:spPr>
         <p:txBody>
-          <a:bodyPr wrap="square" anchor="ctr" lIns="45720" rIns="45720" tIns="27432" bIns="27432">
+          <a:bodyPr wrap="square" lIns="45720" tIns="27432" rIns="45720" bIns="27432" anchor="ctr">
             <a:spAutoFit/>
           </a:bodyPr>
           <a:lstStyle/>
@@ -7530,6 +7672,7 @@
           <a:lstStyle/>
           <a:p>
             <a:pPr algn="ctr"/>
+            <a:endParaRPr/>
           </a:p>
         </p:txBody>
       </p:sp>
@@ -7574,6 +7717,7 @@
           <a:lstStyle/>
           <a:p>
             <a:pPr algn="ctr"/>
+            <a:endParaRPr/>
           </a:p>
         </p:txBody>
       </p:sp>
@@ -7594,7 +7738,7 @@
           <a:noFill/>
         </p:spPr>
         <p:txBody>
-          <a:bodyPr wrap="square" anchor="t" lIns="45720" rIns="45720" tIns="27432" bIns="27432">
+          <a:bodyPr wrap="square" lIns="45720" tIns="27432" rIns="45720" bIns="27432" anchor="t">
             <a:spAutoFit/>
           </a:bodyPr>
           <a:lstStyle/>
@@ -7633,7 +7777,7 @@
           <a:noFill/>
         </p:spPr>
         <p:txBody>
-          <a:bodyPr wrap="square" anchor="b" lIns="45720" rIns="45720" tIns="27432" bIns="27432">
+          <a:bodyPr wrap="square" lIns="45720" tIns="27432" rIns="45720" bIns="27432" anchor="b">
             <a:spAutoFit/>
           </a:bodyPr>
           <a:lstStyle/>
@@ -7696,6 +7840,7 @@
           <a:lstStyle/>
           <a:p>
             <a:pPr algn="ctr"/>
+            <a:endParaRPr/>
           </a:p>
         </p:txBody>
       </p:sp>
@@ -7716,7 +7861,7 @@
           <a:noFill/>
         </p:spPr>
         <p:txBody>
-          <a:bodyPr wrap="square" anchor="t" lIns="45720" rIns="45720" tIns="27432" bIns="27432">
+          <a:bodyPr wrap="square" lIns="45720" tIns="27432" rIns="45720" bIns="27432" anchor="t">
             <a:spAutoFit/>
           </a:bodyPr>
           <a:lstStyle/>
@@ -7755,7 +7900,7 @@
           <a:noFill/>
         </p:spPr>
         <p:txBody>
-          <a:bodyPr wrap="square" anchor="t" lIns="45720" rIns="45720" tIns="27432" bIns="27432">
+          <a:bodyPr wrap="square" lIns="45720" tIns="27432" rIns="45720" bIns="27432" anchor="t">
             <a:spAutoFit/>
           </a:bodyPr>
           <a:lstStyle/>
@@ -7818,6 +7963,7 @@
           <a:lstStyle/>
           <a:p>
             <a:pPr algn="ctr"/>
+            <a:endParaRPr/>
           </a:p>
         </p:txBody>
       </p:sp>
@@ -7838,7 +7984,7 @@
           <a:noFill/>
         </p:spPr>
         <p:txBody>
-          <a:bodyPr wrap="square" anchor="t" lIns="45720" rIns="45720" tIns="27432" bIns="27432">
+          <a:bodyPr wrap="square" lIns="45720" tIns="27432" rIns="45720" bIns="27432" anchor="t">
             <a:spAutoFit/>
           </a:bodyPr>
           <a:lstStyle/>
@@ -7877,7 +8023,7 @@
           <a:noFill/>
         </p:spPr>
         <p:txBody>
-          <a:bodyPr wrap="square" anchor="b" lIns="45720" rIns="45720" tIns="27432" bIns="27432">
+          <a:bodyPr wrap="square" lIns="45720" tIns="27432" rIns="45720" bIns="27432" anchor="b">
             <a:spAutoFit/>
           </a:bodyPr>
           <a:lstStyle/>
@@ -7940,6 +8086,7 @@
           <a:lstStyle/>
           <a:p>
             <a:pPr algn="ctr"/>
+            <a:endParaRPr/>
           </a:p>
         </p:txBody>
       </p:sp>
@@ -7960,7 +8107,7 @@
           <a:noFill/>
         </p:spPr>
         <p:txBody>
-          <a:bodyPr wrap="square" anchor="t" lIns="45720" rIns="45720" tIns="27432" bIns="27432">
+          <a:bodyPr wrap="square" lIns="45720" tIns="27432" rIns="45720" bIns="27432" anchor="t">
             <a:spAutoFit/>
           </a:bodyPr>
           <a:lstStyle/>
@@ -7999,7 +8146,7 @@
           <a:noFill/>
         </p:spPr>
         <p:txBody>
-          <a:bodyPr wrap="square" anchor="t" lIns="45720" rIns="45720" tIns="27432" bIns="27432">
+          <a:bodyPr wrap="square" lIns="45720" tIns="27432" rIns="45720" bIns="27432" anchor="t">
             <a:spAutoFit/>
           </a:bodyPr>
           <a:lstStyle/>
@@ -8062,6 +8209,7 @@
           <a:lstStyle/>
           <a:p>
             <a:pPr algn="ctr"/>
+            <a:endParaRPr/>
           </a:p>
         </p:txBody>
       </p:sp>
@@ -8082,7 +8230,7 @@
           <a:noFill/>
         </p:spPr>
         <p:txBody>
-          <a:bodyPr wrap="square" anchor="t" lIns="45720" rIns="45720" tIns="27432" bIns="27432">
+          <a:bodyPr wrap="square" lIns="45720" tIns="27432" rIns="45720" bIns="27432" anchor="t">
             <a:spAutoFit/>
           </a:bodyPr>
           <a:lstStyle/>
@@ -8121,7 +8269,7 @@
           <a:noFill/>
         </p:spPr>
         <p:txBody>
-          <a:bodyPr wrap="square" anchor="b" lIns="45720" rIns="45720" tIns="27432" bIns="27432">
+          <a:bodyPr wrap="square" lIns="45720" tIns="27432" rIns="45720" bIns="27432" anchor="b">
             <a:spAutoFit/>
           </a:bodyPr>
           <a:lstStyle/>
@@ -8184,6 +8332,7 @@
           <a:lstStyle/>
           <a:p>
             <a:pPr algn="ctr"/>
+            <a:endParaRPr/>
           </a:p>
         </p:txBody>
       </p:sp>
@@ -8204,7 +8353,7 @@
           <a:noFill/>
         </p:spPr>
         <p:txBody>
-          <a:bodyPr wrap="square" anchor="t" lIns="45720" rIns="45720" tIns="27432" bIns="27432">
+          <a:bodyPr wrap="square" lIns="45720" tIns="27432" rIns="45720" bIns="27432" anchor="t">
             <a:spAutoFit/>
           </a:bodyPr>
           <a:lstStyle/>
@@ -8243,7 +8392,7 @@
           <a:noFill/>
         </p:spPr>
         <p:txBody>
-          <a:bodyPr wrap="square" anchor="t" lIns="45720" rIns="45720" tIns="27432" bIns="27432">
+          <a:bodyPr wrap="square" lIns="45720" tIns="27432" rIns="45720" bIns="27432" anchor="t">
             <a:spAutoFit/>
           </a:bodyPr>
           <a:lstStyle/>
@@ -8306,6 +8455,7 @@
           <a:lstStyle/>
           <a:p>
             <a:pPr algn="ctr"/>
+            <a:endParaRPr/>
           </a:p>
         </p:txBody>
       </p:sp>
@@ -8326,7 +8476,7 @@
           <a:noFill/>
         </p:spPr>
         <p:txBody>
-          <a:bodyPr wrap="square" anchor="t" lIns="45720" rIns="45720" tIns="27432" bIns="27432">
+          <a:bodyPr wrap="square" lIns="45720" tIns="27432" rIns="45720" bIns="27432" anchor="t">
             <a:spAutoFit/>
           </a:bodyPr>
           <a:lstStyle/>
@@ -8365,7 +8515,7 @@
           <a:noFill/>
         </p:spPr>
         <p:txBody>
-          <a:bodyPr wrap="square" anchor="b" lIns="45720" rIns="45720" tIns="27432" bIns="27432">
+          <a:bodyPr wrap="square" lIns="45720" tIns="27432" rIns="45720" bIns="27432" anchor="b">
             <a:spAutoFit/>
           </a:bodyPr>
           <a:lstStyle/>
@@ -8428,6 +8578,7 @@
           <a:lstStyle/>
           <a:p>
             <a:pPr algn="ctr"/>
+            <a:endParaRPr/>
           </a:p>
         </p:txBody>
       </p:sp>
@@ -8472,6 +8623,7 @@
           <a:lstStyle/>
           <a:p>
             <a:pPr algn="ctr"/>
+            <a:endParaRPr/>
           </a:p>
         </p:txBody>
       </p:sp>
@@ -8492,7 +8644,7 @@
           <a:noFill/>
         </p:spPr>
         <p:txBody>
-          <a:bodyPr wrap="square" anchor="ctr" lIns="45720" rIns="45720" tIns="27432" bIns="27432">
+          <a:bodyPr wrap="square" lIns="45720" tIns="27432" rIns="45720" bIns="27432" anchor="ctr">
             <a:spAutoFit/>
           </a:bodyPr>
           <a:lstStyle/>
@@ -8540,7 +8692,7 @@
           <a:noFill/>
         </p:spPr>
         <p:txBody>
-          <a:bodyPr wrap="square" anchor="t" lIns="45720" rIns="45720" tIns="27432" bIns="27432">
+          <a:bodyPr wrap="square" lIns="45720" tIns="27432" rIns="45720" bIns="27432" anchor="t">
             <a:spAutoFit/>
           </a:bodyPr>
           <a:lstStyle/>
@@ -8579,7 +8731,7 @@
           <a:noFill/>
         </p:spPr>
         <p:txBody>
-          <a:bodyPr wrap="square" anchor="t" lIns="45720" rIns="45720" tIns="27432" bIns="27432">
+          <a:bodyPr wrap="square" lIns="45720" tIns="27432" rIns="45720" bIns="27432" anchor="t">
             <a:spAutoFit/>
           </a:bodyPr>
           <a:lstStyle/>
@@ -8610,7 +8762,7 @@
 </file>
 
 <file path=ppt/slides/slide16.xml><?xml version="1.0" encoding="utf-8"?>
-<p:sld xmlns:a="http://schemas.openxmlformats.org/drawingml/2006/main" xmlns:p="http://schemas.openxmlformats.org/presentationml/2006/main" xmlns:r="http://schemas.openxmlformats.org/officeDocument/2006/relationships">
+<p:sld xmlns:a="http://schemas.openxmlformats.org/drawingml/2006/main" xmlns:r="http://schemas.openxmlformats.org/officeDocument/2006/relationships" xmlns:p="http://schemas.openxmlformats.org/presentationml/2006/main">
   <p:cSld>
     <p:spTree>
       <p:nvGrpSpPr>
@@ -8618,7 +8770,14 @@
         <p:cNvGrpSpPr/>
         <p:nvPr/>
       </p:nvGrpSpPr>
-      <p:grpSpPr/>
+      <p:grpSpPr>
+        <a:xfrm>
+          <a:off x="0" y="0"/>
+          <a:ext cx="0" cy="0"/>
+          <a:chOff x="0" y="0"/>
+          <a:chExt cx="0" cy="0"/>
+        </a:xfrm>
+      </p:grpSpPr>
       <p:sp>
         <p:nvSpPr>
           <p:cNvPr id="2" name="Rectangle 1"/>
@@ -8660,6 +8819,7 @@
           <a:lstStyle/>
           <a:p>
             <a:pPr algn="ctr"/>
+            <a:endParaRPr/>
           </a:p>
         </p:txBody>
       </p:sp>
@@ -8704,6 +8864,7 @@
           <a:lstStyle/>
           <a:p>
             <a:pPr algn="ctr"/>
+            <a:endParaRPr/>
           </a:p>
         </p:txBody>
       </p:sp>
@@ -8750,6 +8911,7 @@
           <a:lstStyle/>
           <a:p>
             <a:pPr algn="ctr"/>
+            <a:endParaRPr/>
           </a:p>
         </p:txBody>
       </p:sp>
@@ -8770,7 +8932,7 @@
           <a:noFill/>
         </p:spPr>
         <p:txBody>
-          <a:bodyPr wrap="square" anchor="ctr" lIns="45720" rIns="45720" tIns="27432" bIns="27432">
+          <a:bodyPr wrap="square" lIns="45720" tIns="27432" rIns="45720" bIns="27432" anchor="ctr">
             <a:spAutoFit/>
           </a:bodyPr>
           <a:lstStyle/>
@@ -8809,7 +8971,7 @@
           <a:noFill/>
         </p:spPr>
         <p:txBody>
-          <a:bodyPr wrap="square" anchor="ctr" lIns="45720" rIns="45720" tIns="27432" bIns="27432">
+          <a:bodyPr wrap="square" lIns="45720" tIns="27432" rIns="45720" bIns="27432" anchor="ctr">
             <a:spAutoFit/>
           </a:bodyPr>
           <a:lstStyle/>
@@ -8872,6 +9034,7 @@
           <a:lstStyle/>
           <a:p>
             <a:pPr algn="ctr"/>
+            <a:endParaRPr/>
           </a:p>
         </p:txBody>
       </p:sp>
@@ -8916,6 +9079,7 @@
           <a:lstStyle/>
           <a:p>
             <a:pPr algn="ctr"/>
+            <a:endParaRPr/>
           </a:p>
         </p:txBody>
       </p:sp>
@@ -8936,7 +9100,7 @@
           <a:noFill/>
         </p:spPr>
         <p:txBody>
-          <a:bodyPr wrap="square" anchor="t" lIns="45720" rIns="45720" tIns="27432" bIns="27432">
+          <a:bodyPr wrap="square" lIns="45720" tIns="27432" rIns="45720" bIns="27432" anchor="t">
             <a:spAutoFit/>
           </a:bodyPr>
           <a:lstStyle/>
@@ -8975,7 +9139,7 @@
           <a:noFill/>
         </p:spPr>
         <p:txBody>
-          <a:bodyPr wrap="square" anchor="t" lIns="45720" rIns="45720" tIns="27432" bIns="27432">
+          <a:bodyPr wrap="square" lIns="45720" tIns="27432" rIns="45720" bIns="27432" anchor="t">
             <a:spAutoFit/>
           </a:bodyPr>
           <a:lstStyle/>
@@ -9038,6 +9202,7 @@
           <a:lstStyle/>
           <a:p>
             <a:pPr algn="ctr"/>
+            <a:endParaRPr/>
           </a:p>
         </p:txBody>
       </p:sp>
@@ -9082,6 +9247,7 @@
           <a:lstStyle/>
           <a:p>
             <a:pPr algn="ctr"/>
+            <a:endParaRPr/>
           </a:p>
         </p:txBody>
       </p:sp>
@@ -9102,7 +9268,7 @@
           <a:noFill/>
         </p:spPr>
         <p:txBody>
-          <a:bodyPr wrap="square" anchor="t" lIns="45720" rIns="45720" tIns="27432" bIns="27432">
+          <a:bodyPr wrap="square" lIns="45720" tIns="27432" rIns="45720" bIns="27432" anchor="t">
             <a:spAutoFit/>
           </a:bodyPr>
           <a:lstStyle/>
@@ -9141,7 +9307,7 @@
           <a:noFill/>
         </p:spPr>
         <p:txBody>
-          <a:bodyPr wrap="square" anchor="t" lIns="45720" rIns="45720" tIns="27432" bIns="27432">
+          <a:bodyPr wrap="square" lIns="45720" tIns="27432" rIns="45720" bIns="27432" anchor="t">
             <a:spAutoFit/>
           </a:bodyPr>
           <a:lstStyle/>
@@ -9204,6 +9370,7 @@
           <a:lstStyle/>
           <a:p>
             <a:pPr algn="ctr"/>
+            <a:endParaRPr/>
           </a:p>
         </p:txBody>
       </p:sp>
@@ -9248,6 +9415,7 @@
           <a:lstStyle/>
           <a:p>
             <a:pPr algn="ctr"/>
+            <a:endParaRPr/>
           </a:p>
         </p:txBody>
       </p:sp>
@@ -9268,7 +9436,7 @@
           <a:noFill/>
         </p:spPr>
         <p:txBody>
-          <a:bodyPr wrap="square" anchor="t" lIns="45720" rIns="45720" tIns="27432" bIns="27432">
+          <a:bodyPr wrap="square" lIns="45720" tIns="27432" rIns="45720" bIns="27432" anchor="t">
             <a:spAutoFit/>
           </a:bodyPr>
           <a:lstStyle/>
@@ -9307,7 +9475,7 @@
           <a:noFill/>
         </p:spPr>
         <p:txBody>
-          <a:bodyPr wrap="square" anchor="t" lIns="45720" rIns="45720" tIns="27432" bIns="27432">
+          <a:bodyPr wrap="square" lIns="45720" tIns="27432" rIns="45720" bIns="27432" anchor="t">
             <a:spAutoFit/>
           </a:bodyPr>
           <a:lstStyle/>
@@ -9346,7 +9514,7 @@
           <a:noFill/>
         </p:spPr>
         <p:txBody>
-          <a:bodyPr wrap="square" anchor="t" lIns="45720" rIns="45720" tIns="27432" bIns="27432">
+          <a:bodyPr wrap="square" lIns="45720" tIns="27432" rIns="45720" bIns="27432" anchor="t">
             <a:spAutoFit/>
           </a:bodyPr>
           <a:lstStyle/>
@@ -9385,7 +9553,7 @@
           <a:noFill/>
         </p:spPr>
         <p:txBody>
-          <a:bodyPr wrap="square" anchor="t" lIns="45720" rIns="45720" tIns="27432" bIns="27432">
+          <a:bodyPr wrap="square" lIns="45720" tIns="27432" rIns="45720" bIns="27432" anchor="t">
             <a:spAutoFit/>
           </a:bodyPr>
           <a:lstStyle/>
@@ -9416,7 +9584,7 @@
 </file>
 
 <file path=ppt/slides/slide17.xml><?xml version="1.0" encoding="utf-8"?>
-<p:sld xmlns:a="http://schemas.openxmlformats.org/drawingml/2006/main" xmlns:p="http://schemas.openxmlformats.org/presentationml/2006/main" xmlns:r="http://schemas.openxmlformats.org/officeDocument/2006/relationships">
+<p:sld xmlns:a="http://schemas.openxmlformats.org/drawingml/2006/main" xmlns:r="http://schemas.openxmlformats.org/officeDocument/2006/relationships" xmlns:p="http://schemas.openxmlformats.org/presentationml/2006/main">
   <p:cSld>
     <p:spTree>
       <p:nvGrpSpPr>
@@ -9424,7 +9592,14 @@
         <p:cNvGrpSpPr/>
         <p:nvPr/>
       </p:nvGrpSpPr>
-      <p:grpSpPr/>
+      <p:grpSpPr>
+        <a:xfrm>
+          <a:off x="0" y="0"/>
+          <a:ext cx="0" cy="0"/>
+          <a:chOff x="0" y="0"/>
+          <a:chExt cx="0" cy="0"/>
+        </a:xfrm>
+      </p:grpSpPr>
       <p:sp>
         <p:nvSpPr>
           <p:cNvPr id="2" name="Rectangle 1"/>
@@ -9466,6 +9641,7 @@
           <a:lstStyle/>
           <a:p>
             <a:pPr algn="ctr"/>
+            <a:endParaRPr/>
           </a:p>
         </p:txBody>
       </p:sp>
@@ -9510,6 +9686,7 @@
           <a:lstStyle/>
           <a:p>
             <a:pPr algn="ctr"/>
+            <a:endParaRPr/>
           </a:p>
         </p:txBody>
       </p:sp>
@@ -9556,6 +9733,7 @@
           <a:lstStyle/>
           <a:p>
             <a:pPr algn="ctr"/>
+            <a:endParaRPr/>
           </a:p>
         </p:txBody>
       </p:sp>
@@ -9576,7 +9754,7 @@
           <a:noFill/>
         </p:spPr>
         <p:txBody>
-          <a:bodyPr wrap="square" anchor="ctr" lIns="45720" rIns="45720" tIns="27432" bIns="27432">
+          <a:bodyPr wrap="square" lIns="45720" tIns="27432" rIns="45720" bIns="27432" anchor="ctr">
             <a:spAutoFit/>
           </a:bodyPr>
           <a:lstStyle/>
@@ -9615,7 +9793,7 @@
           <a:noFill/>
         </p:spPr>
         <p:txBody>
-          <a:bodyPr wrap="square" anchor="ctr" lIns="45720" rIns="45720" tIns="27432" bIns="27432">
+          <a:bodyPr wrap="square" lIns="45720" tIns="27432" rIns="45720" bIns="27432" anchor="ctr">
             <a:spAutoFit/>
           </a:bodyPr>
           <a:lstStyle/>
@@ -9678,6 +9856,7 @@
           <a:lstStyle/>
           <a:p>
             <a:pPr algn="ctr"/>
+            <a:endParaRPr/>
           </a:p>
         </p:txBody>
       </p:sp>
@@ -9722,6 +9901,7 @@
           <a:lstStyle/>
           <a:p>
             <a:pPr algn="ctr"/>
+            <a:endParaRPr/>
           </a:p>
         </p:txBody>
       </p:sp>
@@ -9742,7 +9922,7 @@
           <a:noFill/>
         </p:spPr>
         <p:txBody>
-          <a:bodyPr wrap="square" anchor="t" lIns="45720" rIns="45720" tIns="27432" bIns="27432">
+          <a:bodyPr wrap="square" lIns="45720" tIns="27432" rIns="45720" bIns="27432" anchor="t">
             <a:spAutoFit/>
           </a:bodyPr>
           <a:lstStyle/>
@@ -9781,7 +9961,7 @@
           <a:noFill/>
         </p:spPr>
         <p:txBody>
-          <a:bodyPr wrap="square" anchor="t" lIns="45720" rIns="45720" tIns="27432" bIns="27432">
+          <a:bodyPr wrap="square" lIns="45720" tIns="27432" rIns="45720" bIns="27432" anchor="t">
             <a:spAutoFit/>
           </a:bodyPr>
           <a:lstStyle/>
@@ -9844,6 +10024,7 @@
           <a:lstStyle/>
           <a:p>
             <a:pPr algn="ctr"/>
+            <a:endParaRPr/>
           </a:p>
         </p:txBody>
       </p:sp>
@@ -9888,6 +10069,7 @@
           <a:lstStyle/>
           <a:p>
             <a:pPr algn="ctr"/>
+            <a:endParaRPr/>
           </a:p>
         </p:txBody>
       </p:sp>
@@ -9908,7 +10090,7 @@
           <a:noFill/>
         </p:spPr>
         <p:txBody>
-          <a:bodyPr wrap="square" anchor="t" lIns="45720" rIns="45720" tIns="27432" bIns="27432">
+          <a:bodyPr wrap="square" lIns="45720" tIns="27432" rIns="45720" bIns="27432" anchor="t">
             <a:spAutoFit/>
           </a:bodyPr>
           <a:lstStyle/>
@@ -9947,7 +10129,7 @@
           <a:noFill/>
         </p:spPr>
         <p:txBody>
-          <a:bodyPr wrap="square" anchor="t" lIns="45720" rIns="45720" tIns="27432" bIns="27432">
+          <a:bodyPr wrap="square" lIns="45720" tIns="27432" rIns="45720" bIns="27432" anchor="t">
             <a:spAutoFit/>
           </a:bodyPr>
           <a:lstStyle/>
@@ -10010,6 +10192,7 @@
           <a:lstStyle/>
           <a:p>
             <a:pPr algn="ctr"/>
+            <a:endParaRPr/>
           </a:p>
         </p:txBody>
       </p:sp>
@@ -10054,6 +10237,7 @@
           <a:lstStyle/>
           <a:p>
             <a:pPr algn="ctr"/>
+            <a:endParaRPr/>
           </a:p>
         </p:txBody>
       </p:sp>
@@ -10074,7 +10258,7 @@
           <a:noFill/>
         </p:spPr>
         <p:txBody>
-          <a:bodyPr wrap="square" anchor="t" lIns="45720" rIns="45720" tIns="27432" bIns="27432">
+          <a:bodyPr wrap="square" lIns="45720" tIns="27432" rIns="45720" bIns="27432" anchor="t">
             <a:spAutoFit/>
           </a:bodyPr>
           <a:lstStyle/>
@@ -10113,7 +10297,7 @@
           <a:noFill/>
         </p:spPr>
         <p:txBody>
-          <a:bodyPr wrap="square" anchor="t" lIns="45720" rIns="45720" tIns="27432" bIns="27432">
+          <a:bodyPr wrap="square" lIns="45720" tIns="27432" rIns="45720" bIns="27432" anchor="t">
             <a:spAutoFit/>
           </a:bodyPr>
           <a:lstStyle/>
@@ -10176,6 +10360,7 @@
           <a:lstStyle/>
           <a:p>
             <a:pPr algn="ctr"/>
+            <a:endParaRPr/>
           </a:p>
         </p:txBody>
       </p:sp>
@@ -10220,6 +10405,7 @@
           <a:lstStyle/>
           <a:p>
             <a:pPr algn="ctr"/>
+            <a:endParaRPr/>
           </a:p>
         </p:txBody>
       </p:sp>
@@ -10240,7 +10426,7 @@
           <a:noFill/>
         </p:spPr>
         <p:txBody>
-          <a:bodyPr wrap="square" anchor="t" lIns="45720" rIns="45720" tIns="27432" bIns="27432">
+          <a:bodyPr wrap="square" lIns="45720" tIns="27432" rIns="45720" bIns="27432" anchor="t">
             <a:spAutoFit/>
           </a:bodyPr>
           <a:lstStyle/>
@@ -10279,7 +10465,7 @@
           <a:noFill/>
         </p:spPr>
         <p:txBody>
-          <a:bodyPr wrap="square" anchor="t" lIns="45720" rIns="45720" tIns="27432" bIns="27432">
+          <a:bodyPr wrap="square" lIns="45720" tIns="27432" rIns="45720" bIns="27432" anchor="t">
             <a:spAutoFit/>
           </a:bodyPr>
           <a:lstStyle/>
@@ -10342,6 +10528,7 @@
           <a:lstStyle/>
           <a:p>
             <a:pPr algn="ctr"/>
+            <a:endParaRPr/>
           </a:p>
         </p:txBody>
       </p:sp>
@@ -10386,6 +10573,7 @@
           <a:lstStyle/>
           <a:p>
             <a:pPr algn="ctr"/>
+            <a:endParaRPr/>
           </a:p>
         </p:txBody>
       </p:sp>
@@ -10406,7 +10594,7 @@
           <a:noFill/>
         </p:spPr>
         <p:txBody>
-          <a:bodyPr wrap="square" anchor="t" lIns="45720" rIns="45720" tIns="27432" bIns="27432">
+          <a:bodyPr wrap="square" lIns="45720" tIns="27432" rIns="45720" bIns="27432" anchor="t">
             <a:spAutoFit/>
           </a:bodyPr>
           <a:lstStyle/>
@@ -10445,7 +10633,7 @@
           <a:noFill/>
         </p:spPr>
         <p:txBody>
-          <a:bodyPr wrap="square" anchor="t" lIns="45720" rIns="45720" tIns="27432" bIns="27432">
+          <a:bodyPr wrap="square" lIns="45720" tIns="27432" rIns="45720" bIns="27432" anchor="t">
             <a:spAutoFit/>
           </a:bodyPr>
           <a:lstStyle/>
@@ -10508,6 +10696,7 @@
           <a:lstStyle/>
           <a:p>
             <a:pPr algn="ctr"/>
+            <a:endParaRPr/>
           </a:p>
         </p:txBody>
       </p:sp>
@@ -10552,6 +10741,7 @@
           <a:lstStyle/>
           <a:p>
             <a:pPr algn="ctr"/>
+            <a:endParaRPr/>
           </a:p>
         </p:txBody>
       </p:sp>
@@ -10572,7 +10762,7 @@
           <a:noFill/>
         </p:spPr>
         <p:txBody>
-          <a:bodyPr wrap="square" anchor="t" lIns="45720" rIns="45720" tIns="27432" bIns="27432">
+          <a:bodyPr wrap="square" lIns="45720" tIns="27432" rIns="45720" bIns="27432" anchor="t">
             <a:spAutoFit/>
           </a:bodyPr>
           <a:lstStyle/>
@@ -10611,7 +10801,7 @@
           <a:noFill/>
         </p:spPr>
         <p:txBody>
-          <a:bodyPr wrap="square" anchor="t" lIns="45720" rIns="45720" tIns="27432" bIns="27432">
+          <a:bodyPr wrap="square" lIns="45720" tIns="27432" rIns="45720" bIns="27432" anchor="t">
             <a:spAutoFit/>
           </a:bodyPr>
           <a:lstStyle/>
@@ -10674,6 +10864,7 @@
           <a:lstStyle/>
           <a:p>
             <a:pPr algn="ctr"/>
+            <a:endParaRPr/>
           </a:p>
         </p:txBody>
       </p:sp>
@@ -10718,6 +10909,7 @@
           <a:lstStyle/>
           <a:p>
             <a:pPr algn="ctr"/>
+            <a:endParaRPr/>
           </a:p>
         </p:txBody>
       </p:sp>
@@ -10738,7 +10930,7 @@
           <a:noFill/>
         </p:spPr>
         <p:txBody>
-          <a:bodyPr wrap="square" anchor="t" lIns="45720" rIns="45720" tIns="27432" bIns="27432">
+          <a:bodyPr wrap="square" lIns="45720" tIns="27432" rIns="45720" bIns="27432" anchor="t">
             <a:spAutoFit/>
           </a:bodyPr>
           <a:lstStyle/>
@@ -10777,7 +10969,7 @@
           <a:noFill/>
         </p:spPr>
         <p:txBody>
-          <a:bodyPr wrap="square" anchor="t" lIns="45720" rIns="45720" tIns="27432" bIns="27432">
+          <a:bodyPr wrap="square" lIns="45720" tIns="27432" rIns="45720" bIns="27432" anchor="t">
             <a:spAutoFit/>
           </a:bodyPr>
           <a:lstStyle/>
@@ -10840,6 +11032,7 @@
           <a:lstStyle/>
           <a:p>
             <a:pPr algn="ctr"/>
+            <a:endParaRPr/>
           </a:p>
         </p:txBody>
       </p:sp>
@@ -10884,6 +11077,7 @@
           <a:lstStyle/>
           <a:p>
             <a:pPr algn="ctr"/>
+            <a:endParaRPr/>
           </a:p>
         </p:txBody>
       </p:sp>
@@ -10904,7 +11098,7 @@
           <a:noFill/>
         </p:spPr>
         <p:txBody>
-          <a:bodyPr wrap="square" anchor="t" lIns="45720" rIns="45720" tIns="27432" bIns="27432">
+          <a:bodyPr wrap="square" lIns="45720" tIns="27432" rIns="45720" bIns="27432" anchor="t">
             <a:spAutoFit/>
           </a:bodyPr>
           <a:lstStyle/>
@@ -10943,7 +11137,7 @@
           <a:noFill/>
         </p:spPr>
         <p:txBody>
-          <a:bodyPr wrap="square" anchor="t" lIns="45720" rIns="45720" tIns="27432" bIns="27432">
+          <a:bodyPr wrap="square" lIns="45720" tIns="27432" rIns="45720" bIns="27432" anchor="t">
             <a:spAutoFit/>
           </a:bodyPr>
           <a:lstStyle/>
@@ -11006,6 +11200,7 @@
           <a:lstStyle/>
           <a:p>
             <a:pPr algn="ctr"/>
+            <a:endParaRPr/>
           </a:p>
         </p:txBody>
       </p:sp>
@@ -11050,6 +11245,7 @@
           <a:lstStyle/>
           <a:p>
             <a:pPr algn="ctr"/>
+            <a:endParaRPr/>
           </a:p>
         </p:txBody>
       </p:sp>
@@ -11070,7 +11266,7 @@
           <a:noFill/>
         </p:spPr>
         <p:txBody>
-          <a:bodyPr wrap="square" anchor="t" lIns="45720" rIns="45720" tIns="27432" bIns="27432">
+          <a:bodyPr wrap="square" lIns="45720" tIns="27432" rIns="45720" bIns="27432" anchor="t">
             <a:spAutoFit/>
           </a:bodyPr>
           <a:lstStyle/>
@@ -11109,7 +11305,7 @@
           <a:noFill/>
         </p:spPr>
         <p:txBody>
-          <a:bodyPr wrap="square" anchor="t" lIns="45720" rIns="45720" tIns="27432" bIns="27432">
+          <a:bodyPr wrap="square" lIns="45720" tIns="27432" rIns="45720" bIns="27432" anchor="t">
             <a:spAutoFit/>
           </a:bodyPr>
           <a:lstStyle/>
@@ -11148,7 +11344,7 @@
           <a:noFill/>
         </p:spPr>
         <p:txBody>
-          <a:bodyPr wrap="square" anchor="t" lIns="45720" rIns="45720" tIns="27432" bIns="27432">
+          <a:bodyPr wrap="square" lIns="45720" tIns="27432" rIns="45720" bIns="27432" anchor="t">
             <a:spAutoFit/>
           </a:bodyPr>
           <a:lstStyle/>
@@ -11187,7 +11383,7 @@
           <a:noFill/>
         </p:spPr>
         <p:txBody>
-          <a:bodyPr wrap="square" anchor="t" lIns="45720" rIns="45720" tIns="27432" bIns="27432">
+          <a:bodyPr wrap="square" lIns="45720" tIns="27432" rIns="45720" bIns="27432" anchor="t">
             <a:spAutoFit/>
           </a:bodyPr>
           <a:lstStyle/>
@@ -11218,7 +11414,7 @@
 </file>
 
 <file path=ppt/slides/slide18.xml><?xml version="1.0" encoding="utf-8"?>
-<p:sld xmlns:a="http://schemas.openxmlformats.org/drawingml/2006/main" xmlns:p="http://schemas.openxmlformats.org/presentationml/2006/main" xmlns:r="http://schemas.openxmlformats.org/officeDocument/2006/relationships">
+<p:sld xmlns:a="http://schemas.openxmlformats.org/drawingml/2006/main" xmlns:r="http://schemas.openxmlformats.org/officeDocument/2006/relationships" xmlns:p="http://schemas.openxmlformats.org/presentationml/2006/main">
   <p:cSld>
     <p:spTree>
       <p:nvGrpSpPr>
@@ -11226,7 +11422,14 @@
         <p:cNvGrpSpPr/>
         <p:nvPr/>
       </p:nvGrpSpPr>
-      <p:grpSpPr/>
+      <p:grpSpPr>
+        <a:xfrm>
+          <a:off x="0" y="0"/>
+          <a:ext cx="0" cy="0"/>
+          <a:chOff x="0" y="0"/>
+          <a:chExt cx="0" cy="0"/>
+        </a:xfrm>
+      </p:grpSpPr>
       <p:sp>
         <p:nvSpPr>
           <p:cNvPr id="2" name="Rectangle 1"/>
@@ -11268,6 +11471,7 @@
           <a:lstStyle/>
           <a:p>
             <a:pPr algn="ctr"/>
+            <a:endParaRPr/>
           </a:p>
         </p:txBody>
       </p:sp>
@@ -11312,6 +11516,7 @@
           <a:lstStyle/>
           <a:p>
             <a:pPr algn="ctr"/>
+            <a:endParaRPr/>
           </a:p>
         </p:txBody>
       </p:sp>
@@ -11332,7 +11537,7 @@
           <a:noFill/>
         </p:spPr>
         <p:txBody>
-          <a:bodyPr wrap="square" anchor="t" lIns="45720" rIns="45720" tIns="27432" bIns="27432">
+          <a:bodyPr wrap="square" lIns="45720" tIns="27432" rIns="45720" bIns="27432" anchor="t">
             <a:spAutoFit/>
           </a:bodyPr>
           <a:lstStyle/>
@@ -11371,7 +11576,7 @@
           <a:noFill/>
         </p:spPr>
         <p:txBody>
-          <a:bodyPr wrap="square" anchor="t" lIns="45720" rIns="45720" tIns="27432" bIns="27432">
+          <a:bodyPr wrap="square" lIns="45720" tIns="27432" rIns="45720" bIns="27432" anchor="t">
             <a:spAutoFit/>
           </a:bodyPr>
           <a:lstStyle/>
@@ -11554,7 +11759,7 @@
 </file>
 
 <file path=ppt/slides/slide2.xml><?xml version="1.0" encoding="utf-8"?>
-<p:sld xmlns:a="http://schemas.openxmlformats.org/drawingml/2006/main" xmlns:p="http://schemas.openxmlformats.org/presentationml/2006/main" xmlns:r="http://schemas.openxmlformats.org/officeDocument/2006/relationships">
+<p:sld xmlns:a="http://schemas.openxmlformats.org/drawingml/2006/main" xmlns:r="http://schemas.openxmlformats.org/officeDocument/2006/relationships" xmlns:p="http://schemas.openxmlformats.org/presentationml/2006/main">
   <p:cSld>
     <p:spTree>
       <p:nvGrpSpPr>
@@ -11562,7 +11767,14 @@
         <p:cNvGrpSpPr/>
         <p:nvPr/>
       </p:nvGrpSpPr>
-      <p:grpSpPr/>
+      <p:grpSpPr>
+        <a:xfrm>
+          <a:off x="0" y="0"/>
+          <a:ext cx="0" cy="0"/>
+          <a:chOff x="0" y="0"/>
+          <a:chExt cx="0" cy="0"/>
+        </a:xfrm>
+      </p:grpSpPr>
       <p:sp>
         <p:nvSpPr>
           <p:cNvPr id="2" name="Rectangle 1"/>
@@ -11604,6 +11816,7 @@
           <a:lstStyle/>
           <a:p>
             <a:pPr algn="ctr"/>
+            <a:endParaRPr/>
           </a:p>
         </p:txBody>
       </p:sp>
@@ -11648,6 +11861,7 @@
           <a:lstStyle/>
           <a:p>
             <a:pPr algn="ctr"/>
+            <a:endParaRPr/>
           </a:p>
         </p:txBody>
       </p:sp>
@@ -11668,7 +11882,7 @@
           <a:noFill/>
         </p:spPr>
         <p:txBody>
-          <a:bodyPr wrap="square" anchor="ctr" lIns="45720" rIns="45720" tIns="27432" bIns="27432">
+          <a:bodyPr wrap="square" lIns="45720" tIns="27432" rIns="45720" bIns="27432" anchor="ctr">
             <a:spAutoFit/>
           </a:bodyPr>
           <a:lstStyle/>
@@ -11707,7 +11921,7 @@
           <a:noFill/>
         </p:spPr>
         <p:txBody>
-          <a:bodyPr wrap="square" anchor="t" lIns="45720" rIns="45720" tIns="27432" bIns="27432">
+          <a:bodyPr wrap="square" lIns="45720" tIns="27432" rIns="45720" bIns="27432" anchor="t">
             <a:spAutoFit/>
           </a:bodyPr>
           <a:lstStyle/>
@@ -11779,6 +11993,7 @@
           <a:lstStyle/>
           <a:p>
             <a:pPr algn="ctr"/>
+            <a:endParaRPr/>
           </a:p>
         </p:txBody>
       </p:sp>
@@ -11823,6 +12038,7 @@
           <a:lstStyle/>
           <a:p>
             <a:pPr algn="ctr"/>
+            <a:endParaRPr/>
           </a:p>
         </p:txBody>
       </p:sp>
@@ -11843,7 +12059,7 @@
           <a:noFill/>
         </p:spPr>
         <p:txBody>
-          <a:bodyPr wrap="square" anchor="t" lIns="45720" rIns="45720" tIns="27432" bIns="27432">
+          <a:bodyPr wrap="square" lIns="45720" tIns="27432" rIns="45720" bIns="27432" anchor="t">
             <a:spAutoFit/>
           </a:bodyPr>
           <a:lstStyle/>
@@ -11882,7 +12098,7 @@
           <a:noFill/>
         </p:spPr>
         <p:txBody>
-          <a:bodyPr wrap="square" anchor="t" lIns="45720" rIns="45720" tIns="27432" bIns="27432">
+          <a:bodyPr wrap="square" lIns="45720" tIns="27432" rIns="45720" bIns="27432" anchor="t">
             <a:spAutoFit/>
           </a:bodyPr>
           <a:lstStyle/>
@@ -11921,7 +12137,7 @@
           <a:noFill/>
         </p:spPr>
         <p:txBody>
-          <a:bodyPr wrap="square" anchor="t" lIns="45720" rIns="45720" tIns="27432" bIns="27432">
+          <a:bodyPr wrap="square" lIns="45720" tIns="27432" rIns="45720" bIns="27432" anchor="t">
             <a:spAutoFit/>
           </a:bodyPr>
           <a:lstStyle/>
@@ -11984,6 +12200,7 @@
           <a:lstStyle/>
           <a:p>
             <a:pPr algn="ctr"/>
+            <a:endParaRPr/>
           </a:p>
         </p:txBody>
       </p:sp>
@@ -12028,6 +12245,7 @@
           <a:lstStyle/>
           <a:p>
             <a:pPr algn="ctr"/>
+            <a:endParaRPr/>
           </a:p>
         </p:txBody>
       </p:sp>
@@ -12048,7 +12266,7 @@
           <a:noFill/>
         </p:spPr>
         <p:txBody>
-          <a:bodyPr wrap="square" anchor="t" lIns="45720" rIns="45720" tIns="27432" bIns="27432">
+          <a:bodyPr wrap="square" lIns="45720" tIns="27432" rIns="45720" bIns="27432" anchor="t">
             <a:spAutoFit/>
           </a:bodyPr>
           <a:lstStyle/>
@@ -12087,7 +12305,7 @@
           <a:noFill/>
         </p:spPr>
         <p:txBody>
-          <a:bodyPr wrap="square" anchor="t" lIns="45720" rIns="45720" tIns="27432" bIns="27432">
+          <a:bodyPr wrap="square" lIns="45720" tIns="27432" rIns="45720" bIns="27432" anchor="t">
             <a:spAutoFit/>
           </a:bodyPr>
           <a:lstStyle/>
@@ -12126,7 +12344,7 @@
           <a:noFill/>
         </p:spPr>
         <p:txBody>
-          <a:bodyPr wrap="square" anchor="t" lIns="45720" rIns="45720" tIns="27432" bIns="27432">
+          <a:bodyPr wrap="square" lIns="45720" tIns="27432" rIns="45720" bIns="27432" anchor="t">
             <a:spAutoFit/>
           </a:bodyPr>
           <a:lstStyle/>
@@ -12189,6 +12407,7 @@
           <a:lstStyle/>
           <a:p>
             <a:pPr algn="ctr"/>
+            <a:endParaRPr/>
           </a:p>
         </p:txBody>
       </p:sp>
@@ -12233,6 +12452,7 @@
           <a:lstStyle/>
           <a:p>
             <a:pPr algn="ctr"/>
+            <a:endParaRPr/>
           </a:p>
         </p:txBody>
       </p:sp>
@@ -12253,7 +12473,7 @@
           <a:noFill/>
         </p:spPr>
         <p:txBody>
-          <a:bodyPr wrap="square" anchor="t" lIns="45720" rIns="45720" tIns="27432" bIns="27432">
+          <a:bodyPr wrap="square" lIns="45720" tIns="27432" rIns="45720" bIns="27432" anchor="t">
             <a:spAutoFit/>
           </a:bodyPr>
           <a:lstStyle/>
@@ -12292,7 +12512,7 @@
           <a:noFill/>
         </p:spPr>
         <p:txBody>
-          <a:bodyPr wrap="square" anchor="t" lIns="45720" rIns="45720" tIns="27432" bIns="27432">
+          <a:bodyPr wrap="square" lIns="45720" tIns="27432" rIns="45720" bIns="27432" anchor="t">
             <a:spAutoFit/>
           </a:bodyPr>
           <a:lstStyle/>
@@ -12331,7 +12551,7 @@
           <a:noFill/>
         </p:spPr>
         <p:txBody>
-          <a:bodyPr wrap="square" anchor="t" lIns="45720" rIns="45720" tIns="27432" bIns="27432">
+          <a:bodyPr wrap="square" lIns="45720" tIns="27432" rIns="45720" bIns="27432" anchor="t">
             <a:spAutoFit/>
           </a:bodyPr>
           <a:lstStyle/>
@@ -12394,6 +12614,7 @@
           <a:lstStyle/>
           <a:p>
             <a:pPr algn="ctr"/>
+            <a:endParaRPr/>
           </a:p>
         </p:txBody>
       </p:sp>
@@ -12438,6 +12659,7 @@
           <a:lstStyle/>
           <a:p>
             <a:pPr algn="ctr"/>
+            <a:endParaRPr/>
           </a:p>
         </p:txBody>
       </p:sp>
@@ -12458,7 +12680,7 @@
           <a:noFill/>
         </p:spPr>
         <p:txBody>
-          <a:bodyPr wrap="square" anchor="t" lIns="45720" rIns="45720" tIns="27432" bIns="27432">
+          <a:bodyPr wrap="square" lIns="45720" tIns="27432" rIns="45720" bIns="27432" anchor="t">
             <a:spAutoFit/>
           </a:bodyPr>
           <a:lstStyle/>
@@ -12497,7 +12719,7 @@
           <a:noFill/>
         </p:spPr>
         <p:txBody>
-          <a:bodyPr wrap="square" anchor="t" lIns="45720" rIns="45720" tIns="27432" bIns="27432">
+          <a:bodyPr wrap="square" lIns="45720" tIns="27432" rIns="45720" bIns="27432" anchor="t">
             <a:spAutoFit/>
           </a:bodyPr>
           <a:lstStyle/>
@@ -12536,7 +12758,7 @@
           <a:noFill/>
         </p:spPr>
         <p:txBody>
-          <a:bodyPr wrap="square" anchor="t" lIns="45720" rIns="45720" tIns="27432" bIns="27432">
+          <a:bodyPr wrap="square" lIns="45720" tIns="27432" rIns="45720" bIns="27432" anchor="t">
             <a:spAutoFit/>
           </a:bodyPr>
           <a:lstStyle/>
@@ -12560,14 +12782,14 @@
       </p:sp>
       <p:sp>
         <p:nvSpPr>
-          <p:cNvPr id="26" name="TextBox 25"/>
+          <p:cNvPr id="27" name="TextBox 26"/>
           <p:cNvSpPr txBox="1"/>
           <p:nvPr/>
         </p:nvSpPr>
         <p:spPr>
           <a:xfrm>
-            <a:off x="457200" y="5806440"/>
-            <a:ext cx="11247120" cy="548640"/>
+            <a:off x="457200" y="6473952"/>
+            <a:ext cx="8229600" cy="274320"/>
           </a:xfrm>
           <a:prstGeom prst="rect">
             <a:avLst/>
@@ -12575,7 +12797,7 @@
           <a:noFill/>
         </p:spPr>
         <p:txBody>
-          <a:bodyPr wrap="square" anchor="t" lIns="45720" rIns="45720" tIns="27432" bIns="27432">
+          <a:bodyPr wrap="square" lIns="45720" tIns="27432" rIns="45720" bIns="27432" anchor="t">
             <a:spAutoFit/>
           </a:bodyPr>
           <a:lstStyle/>
@@ -12586,45 +12808,6 @@
               </a:lnSpc>
             </a:pPr>
             <a:r>
-              <a:rPr sz="1200" b="0" i="0">
-                <a:solidFill>
-                  <a:srgbClr val="5B6675"/>
-                </a:solidFill>
-                <a:latin typeface="Calibri"/>
-              </a:rPr>
-              <a:t>Примечание: данные инцидента (имя узла, адрес C2, имена файлов) условные; снимки экранов — воссозданные интерфейсы Wazuh, pfSense и Sysinternals для иллюстрации порядка действий.</a:t>
-            </a:r>
-          </a:p>
-        </p:txBody>
-      </p:sp>
-      <p:sp>
-        <p:nvSpPr>
-          <p:cNvPr id="27" name="TextBox 26"/>
-          <p:cNvSpPr txBox="1"/>
-          <p:nvPr/>
-        </p:nvSpPr>
-        <p:spPr>
-          <a:xfrm>
-            <a:off x="457200" y="6473952"/>
-            <a:ext cx="8229600" cy="274320"/>
-          </a:xfrm>
-          <a:prstGeom prst="rect">
-            <a:avLst/>
-          </a:prstGeom>
-          <a:noFill/>
-        </p:spPr>
-        <p:txBody>
-          <a:bodyPr wrap="square" anchor="t" lIns="45720" rIns="45720" tIns="27432" bIns="27432">
-            <a:spAutoFit/>
-          </a:bodyPr>
-          <a:lstStyle/>
-          <a:p>
-            <a:pPr algn="l">
-              <a:lnSpc>
-                <a:spcPct val="110000"/>
-              </a:lnSpc>
-            </a:pPr>
-            <a:r>
               <a:rPr sz="1000" b="0" i="0">
                 <a:solidFill>
                   <a:srgbClr val="5B6675"/>
@@ -12653,7 +12836,7 @@
           <a:noFill/>
         </p:spPr>
         <p:txBody>
-          <a:bodyPr wrap="square" anchor="t" lIns="45720" rIns="45720" tIns="27432" bIns="27432">
+          <a:bodyPr wrap="square" lIns="45720" tIns="27432" rIns="45720" bIns="27432" anchor="t">
             <a:spAutoFit/>
           </a:bodyPr>
           <a:lstStyle/>
@@ -12684,7 +12867,7 @@
 </file>
 
 <file path=ppt/slides/slide3.xml><?xml version="1.0" encoding="utf-8"?>
-<p:sld xmlns:a="http://schemas.openxmlformats.org/drawingml/2006/main" xmlns:p="http://schemas.openxmlformats.org/presentationml/2006/main" xmlns:r="http://schemas.openxmlformats.org/officeDocument/2006/relationships">
+<p:sld xmlns:a="http://schemas.openxmlformats.org/drawingml/2006/main" xmlns:r="http://schemas.openxmlformats.org/officeDocument/2006/relationships" xmlns:p="http://schemas.openxmlformats.org/presentationml/2006/main">
   <p:cSld>
     <p:spTree>
       <p:nvGrpSpPr>
@@ -12692,7 +12875,14 @@
         <p:cNvGrpSpPr/>
         <p:nvPr/>
       </p:nvGrpSpPr>
-      <p:grpSpPr/>
+      <p:grpSpPr>
+        <a:xfrm>
+          <a:off x="0" y="0"/>
+          <a:ext cx="0" cy="0"/>
+          <a:chOff x="0" y="0"/>
+          <a:chExt cx="0" cy="0"/>
+        </a:xfrm>
+      </p:grpSpPr>
       <p:sp>
         <p:nvSpPr>
           <p:cNvPr id="2" name="Rectangle 1"/>
@@ -12734,6 +12924,7 @@
           <a:lstStyle/>
           <a:p>
             <a:pPr algn="ctr"/>
+            <a:endParaRPr/>
           </a:p>
         </p:txBody>
       </p:sp>
@@ -12778,6 +12969,7 @@
           <a:lstStyle/>
           <a:p>
             <a:pPr algn="ctr"/>
+            <a:endParaRPr/>
           </a:p>
         </p:txBody>
       </p:sp>
@@ -12824,6 +13016,7 @@
           <a:lstStyle/>
           <a:p>
             <a:pPr algn="ctr"/>
+            <a:endParaRPr/>
           </a:p>
         </p:txBody>
       </p:sp>
@@ -12844,7 +13037,7 @@
           <a:noFill/>
         </p:spPr>
         <p:txBody>
-          <a:bodyPr wrap="square" anchor="ctr" lIns="45720" rIns="45720" tIns="27432" bIns="27432">
+          <a:bodyPr wrap="square" lIns="45720" tIns="27432" rIns="45720" bIns="27432" anchor="ctr">
             <a:spAutoFit/>
           </a:bodyPr>
           <a:lstStyle/>
@@ -12883,7 +13076,7 @@
           <a:noFill/>
         </p:spPr>
         <p:txBody>
-          <a:bodyPr wrap="square" anchor="ctr" lIns="45720" rIns="45720" tIns="27432" bIns="27432">
+          <a:bodyPr wrap="square" lIns="45720" tIns="27432" rIns="45720" bIns="27432" anchor="ctr">
             <a:spAutoFit/>
           </a:bodyPr>
           <a:lstStyle/>
@@ -12946,6 +13139,7 @@
           <a:lstStyle/>
           <a:p>
             <a:pPr algn="ctr"/>
+            <a:endParaRPr/>
           </a:p>
         </p:txBody>
       </p:sp>
@@ -12990,6 +13184,7 @@
           <a:lstStyle/>
           <a:p>
             <a:pPr algn="ctr"/>
+            <a:endParaRPr/>
           </a:p>
         </p:txBody>
       </p:sp>
@@ -13010,7 +13205,7 @@
           <a:noFill/>
         </p:spPr>
         <p:txBody>
-          <a:bodyPr wrap="square" anchor="ctr" lIns="45720" rIns="45720" tIns="27432" bIns="27432">
+          <a:bodyPr wrap="square" lIns="45720" tIns="27432" rIns="45720" bIns="27432" anchor="ctr">
             <a:spAutoFit/>
           </a:bodyPr>
           <a:lstStyle/>
@@ -13049,7 +13244,7 @@
           <a:noFill/>
         </p:spPr>
         <p:txBody>
-          <a:bodyPr wrap="square" anchor="t" lIns="45720" rIns="45720" tIns="27432" bIns="27432">
+          <a:bodyPr wrap="square" lIns="45720" tIns="27432" rIns="45720" bIns="27432" anchor="t">
             <a:spAutoFit/>
           </a:bodyPr>
           <a:lstStyle/>
@@ -13088,7 +13283,7 @@
           <a:noFill/>
         </p:spPr>
         <p:txBody>
-          <a:bodyPr wrap="square" anchor="t" lIns="45720" rIns="45720" tIns="27432" bIns="27432">
+          <a:bodyPr wrap="square" lIns="45720" tIns="27432" rIns="45720" bIns="27432" anchor="t">
             <a:spAutoFit/>
           </a:bodyPr>
           <a:lstStyle/>
@@ -13151,6 +13346,7 @@
           <a:lstStyle/>
           <a:p>
             <a:pPr algn="ctr"/>
+            <a:endParaRPr/>
           </a:p>
         </p:txBody>
       </p:sp>
@@ -13195,6 +13391,7 @@
           <a:lstStyle/>
           <a:p>
             <a:pPr algn="ctr"/>
+            <a:endParaRPr/>
           </a:p>
         </p:txBody>
       </p:sp>
@@ -13215,7 +13412,7 @@
           <a:noFill/>
         </p:spPr>
         <p:txBody>
-          <a:bodyPr wrap="square" anchor="ctr" lIns="45720" rIns="45720" tIns="27432" bIns="27432">
+          <a:bodyPr wrap="square" lIns="45720" tIns="27432" rIns="45720" bIns="27432" anchor="ctr">
             <a:spAutoFit/>
           </a:bodyPr>
           <a:lstStyle/>
@@ -13254,7 +13451,7 @@
           <a:noFill/>
         </p:spPr>
         <p:txBody>
-          <a:bodyPr wrap="square" anchor="t" lIns="45720" rIns="45720" tIns="27432" bIns="27432">
+          <a:bodyPr wrap="square" lIns="45720" tIns="27432" rIns="45720" bIns="27432" anchor="t">
             <a:spAutoFit/>
           </a:bodyPr>
           <a:lstStyle/>
@@ -13293,7 +13490,7 @@
           <a:noFill/>
         </p:spPr>
         <p:txBody>
-          <a:bodyPr wrap="square" anchor="t" lIns="45720" rIns="45720" tIns="27432" bIns="27432">
+          <a:bodyPr wrap="square" lIns="45720" tIns="27432" rIns="45720" bIns="27432" anchor="t">
             <a:spAutoFit/>
           </a:bodyPr>
           <a:lstStyle/>
@@ -13356,6 +13553,7 @@
           <a:lstStyle/>
           <a:p>
             <a:pPr algn="ctr"/>
+            <a:endParaRPr/>
           </a:p>
         </p:txBody>
       </p:sp>
@@ -13400,6 +13598,7 @@
           <a:lstStyle/>
           <a:p>
             <a:pPr algn="ctr"/>
+            <a:endParaRPr/>
           </a:p>
         </p:txBody>
       </p:sp>
@@ -13420,7 +13619,7 @@
           <a:noFill/>
         </p:spPr>
         <p:txBody>
-          <a:bodyPr wrap="square" anchor="ctr" lIns="45720" rIns="45720" tIns="27432" bIns="27432">
+          <a:bodyPr wrap="square" lIns="45720" tIns="27432" rIns="45720" bIns="27432" anchor="ctr">
             <a:spAutoFit/>
           </a:bodyPr>
           <a:lstStyle/>
@@ -13459,7 +13658,7 @@
           <a:noFill/>
         </p:spPr>
         <p:txBody>
-          <a:bodyPr wrap="square" anchor="t" lIns="45720" rIns="45720" tIns="27432" bIns="27432">
+          <a:bodyPr wrap="square" lIns="45720" tIns="27432" rIns="45720" bIns="27432" anchor="t">
             <a:spAutoFit/>
           </a:bodyPr>
           <a:lstStyle/>
@@ -13498,7 +13697,7 @@
           <a:noFill/>
         </p:spPr>
         <p:txBody>
-          <a:bodyPr wrap="square" anchor="t" lIns="45720" rIns="45720" tIns="27432" bIns="27432">
+          <a:bodyPr wrap="square" lIns="45720" tIns="27432" rIns="45720" bIns="27432" anchor="t">
             <a:spAutoFit/>
           </a:bodyPr>
           <a:lstStyle/>
@@ -13561,6 +13760,7 @@
           <a:lstStyle/>
           <a:p>
             <a:pPr algn="ctr"/>
+            <a:endParaRPr/>
           </a:p>
         </p:txBody>
       </p:sp>
@@ -13605,6 +13805,7 @@
           <a:lstStyle/>
           <a:p>
             <a:pPr algn="ctr"/>
+            <a:endParaRPr/>
           </a:p>
         </p:txBody>
       </p:sp>
@@ -13625,7 +13826,7 @@
           <a:noFill/>
         </p:spPr>
         <p:txBody>
-          <a:bodyPr wrap="square" anchor="ctr" lIns="45720" rIns="45720" tIns="27432" bIns="27432">
+          <a:bodyPr wrap="square" lIns="45720" tIns="27432" rIns="45720" bIns="27432" anchor="ctr">
             <a:spAutoFit/>
           </a:bodyPr>
           <a:lstStyle/>
@@ -13664,7 +13865,7 @@
           <a:noFill/>
         </p:spPr>
         <p:txBody>
-          <a:bodyPr wrap="square" anchor="t" lIns="45720" rIns="45720" tIns="27432" bIns="27432">
+          <a:bodyPr wrap="square" lIns="45720" tIns="27432" rIns="45720" bIns="27432" anchor="t">
             <a:spAutoFit/>
           </a:bodyPr>
           <a:lstStyle/>
@@ -13703,7 +13904,7 @@
           <a:noFill/>
         </p:spPr>
         <p:txBody>
-          <a:bodyPr wrap="square" anchor="t" lIns="45720" rIns="45720" tIns="27432" bIns="27432">
+          <a:bodyPr wrap="square" lIns="45720" tIns="27432" rIns="45720" bIns="27432" anchor="t">
             <a:spAutoFit/>
           </a:bodyPr>
           <a:lstStyle/>
@@ -13766,6 +13967,7 @@
           <a:lstStyle/>
           <a:p>
             <a:pPr algn="ctr"/>
+            <a:endParaRPr/>
           </a:p>
         </p:txBody>
       </p:sp>
@@ -13810,6 +14012,7 @@
           <a:lstStyle/>
           <a:p>
             <a:pPr algn="ctr"/>
+            <a:endParaRPr/>
           </a:p>
         </p:txBody>
       </p:sp>
@@ -13830,7 +14033,7 @@
           <a:noFill/>
         </p:spPr>
         <p:txBody>
-          <a:bodyPr wrap="square" anchor="ctr" lIns="45720" rIns="45720" tIns="27432" bIns="27432">
+          <a:bodyPr wrap="square" lIns="45720" tIns="27432" rIns="45720" bIns="27432" anchor="ctr">
             <a:spAutoFit/>
           </a:bodyPr>
           <a:lstStyle/>
@@ -13869,7 +14072,7 @@
           <a:noFill/>
         </p:spPr>
         <p:txBody>
-          <a:bodyPr wrap="square" anchor="t" lIns="45720" rIns="45720" tIns="27432" bIns="27432">
+          <a:bodyPr wrap="square" lIns="45720" tIns="27432" rIns="45720" bIns="27432" anchor="t">
             <a:spAutoFit/>
           </a:bodyPr>
           <a:lstStyle/>
@@ -13908,7 +14111,7 @@
           <a:noFill/>
         </p:spPr>
         <p:txBody>
-          <a:bodyPr wrap="square" anchor="t" lIns="45720" rIns="45720" tIns="27432" bIns="27432">
+          <a:bodyPr wrap="square" lIns="45720" tIns="27432" rIns="45720" bIns="27432" anchor="t">
             <a:spAutoFit/>
           </a:bodyPr>
           <a:lstStyle/>
@@ -13971,6 +14174,7 @@
           <a:lstStyle/>
           <a:p>
             <a:pPr algn="ctr"/>
+            <a:endParaRPr/>
           </a:p>
         </p:txBody>
       </p:sp>
@@ -14015,6 +14219,7 @@
           <a:lstStyle/>
           <a:p>
             <a:pPr algn="ctr"/>
+            <a:endParaRPr/>
           </a:p>
         </p:txBody>
       </p:sp>
@@ -14035,7 +14240,7 @@
           <a:noFill/>
         </p:spPr>
         <p:txBody>
-          <a:bodyPr wrap="square" anchor="ctr" lIns="45720" rIns="45720" tIns="27432" bIns="27432">
+          <a:bodyPr wrap="square" lIns="45720" tIns="27432" rIns="45720" bIns="27432" anchor="ctr">
             <a:spAutoFit/>
           </a:bodyPr>
           <a:lstStyle/>
@@ -14074,7 +14279,7 @@
           <a:noFill/>
         </p:spPr>
         <p:txBody>
-          <a:bodyPr wrap="square" anchor="t" lIns="45720" rIns="45720" tIns="27432" bIns="27432">
+          <a:bodyPr wrap="square" lIns="45720" tIns="27432" rIns="45720" bIns="27432" anchor="t">
             <a:spAutoFit/>
           </a:bodyPr>
           <a:lstStyle/>
@@ -14113,7 +14318,7 @@
           <a:noFill/>
         </p:spPr>
         <p:txBody>
-          <a:bodyPr wrap="square" anchor="t" lIns="45720" rIns="45720" tIns="27432" bIns="27432">
+          <a:bodyPr wrap="square" lIns="45720" tIns="27432" rIns="45720" bIns="27432" anchor="t">
             <a:spAutoFit/>
           </a:bodyPr>
           <a:lstStyle/>
@@ -14176,6 +14381,7 @@
           <a:lstStyle/>
           <a:p>
             <a:pPr algn="ctr"/>
+            <a:endParaRPr/>
           </a:p>
         </p:txBody>
       </p:sp>
@@ -14220,6 +14426,7 @@
           <a:lstStyle/>
           <a:p>
             <a:pPr algn="ctr"/>
+            <a:endParaRPr/>
           </a:p>
         </p:txBody>
       </p:sp>
@@ -14240,7 +14447,7 @@
           <a:noFill/>
         </p:spPr>
         <p:txBody>
-          <a:bodyPr wrap="square" anchor="ctr" lIns="45720" rIns="45720" tIns="27432" bIns="27432">
+          <a:bodyPr wrap="square" lIns="45720" tIns="27432" rIns="45720" bIns="27432" anchor="ctr">
             <a:spAutoFit/>
           </a:bodyPr>
           <a:lstStyle/>
@@ -14279,7 +14486,7 @@
           <a:noFill/>
         </p:spPr>
         <p:txBody>
-          <a:bodyPr wrap="square" anchor="t" lIns="45720" rIns="45720" tIns="27432" bIns="27432">
+          <a:bodyPr wrap="square" lIns="45720" tIns="27432" rIns="45720" bIns="27432" anchor="t">
             <a:spAutoFit/>
           </a:bodyPr>
           <a:lstStyle/>
@@ -14318,7 +14525,7 @@
           <a:noFill/>
         </p:spPr>
         <p:txBody>
-          <a:bodyPr wrap="square" anchor="t" lIns="45720" rIns="45720" tIns="27432" bIns="27432">
+          <a:bodyPr wrap="square" lIns="45720" tIns="27432" rIns="45720" bIns="27432" anchor="t">
             <a:spAutoFit/>
           </a:bodyPr>
           <a:lstStyle/>
@@ -14381,6 +14588,7 @@
           <a:lstStyle/>
           <a:p>
             <a:pPr algn="ctr"/>
+            <a:endParaRPr/>
           </a:p>
         </p:txBody>
       </p:sp>
@@ -14425,6 +14633,7 @@
           <a:lstStyle/>
           <a:p>
             <a:pPr algn="ctr"/>
+            <a:endParaRPr/>
           </a:p>
         </p:txBody>
       </p:sp>
@@ -14445,7 +14654,7 @@
           <a:noFill/>
         </p:spPr>
         <p:txBody>
-          <a:bodyPr wrap="square" anchor="ctr" lIns="45720" rIns="45720" tIns="27432" bIns="27432">
+          <a:bodyPr wrap="square" lIns="45720" tIns="27432" rIns="45720" bIns="27432" anchor="ctr">
             <a:spAutoFit/>
           </a:bodyPr>
           <a:lstStyle/>
@@ -14484,7 +14693,7 @@
           <a:noFill/>
         </p:spPr>
         <p:txBody>
-          <a:bodyPr wrap="square" anchor="t" lIns="45720" rIns="45720" tIns="27432" bIns="27432">
+          <a:bodyPr wrap="square" lIns="45720" tIns="27432" rIns="45720" bIns="27432" anchor="t">
             <a:spAutoFit/>
           </a:bodyPr>
           <a:lstStyle/>
@@ -14523,7 +14732,7 @@
           <a:noFill/>
         </p:spPr>
         <p:txBody>
-          <a:bodyPr wrap="square" anchor="t" lIns="45720" rIns="45720" tIns="27432" bIns="27432">
+          <a:bodyPr wrap="square" lIns="45720" tIns="27432" rIns="45720" bIns="27432" anchor="t">
             <a:spAutoFit/>
           </a:bodyPr>
           <a:lstStyle/>
@@ -14586,6 +14795,7 @@
           <a:lstStyle/>
           <a:p>
             <a:pPr algn="ctr"/>
+            <a:endParaRPr/>
           </a:p>
         </p:txBody>
       </p:sp>
@@ -14630,6 +14840,7 @@
           <a:lstStyle/>
           <a:p>
             <a:pPr algn="ctr"/>
+            <a:endParaRPr/>
           </a:p>
         </p:txBody>
       </p:sp>
@@ -14650,7 +14861,7 @@
           <a:noFill/>
         </p:spPr>
         <p:txBody>
-          <a:bodyPr wrap="square" anchor="ctr" lIns="45720" rIns="45720" tIns="27432" bIns="27432">
+          <a:bodyPr wrap="square" lIns="45720" tIns="27432" rIns="45720" bIns="27432" anchor="ctr">
             <a:spAutoFit/>
           </a:bodyPr>
           <a:lstStyle/>
@@ -14689,7 +14900,7 @@
           <a:noFill/>
         </p:spPr>
         <p:txBody>
-          <a:bodyPr wrap="square" anchor="t" lIns="45720" rIns="45720" tIns="27432" bIns="27432">
+          <a:bodyPr wrap="square" lIns="45720" tIns="27432" rIns="45720" bIns="27432" anchor="t">
             <a:spAutoFit/>
           </a:bodyPr>
           <a:lstStyle/>
@@ -14728,7 +14939,7 @@
           <a:noFill/>
         </p:spPr>
         <p:txBody>
-          <a:bodyPr wrap="square" anchor="t" lIns="45720" rIns="45720" tIns="27432" bIns="27432">
+          <a:bodyPr wrap="square" lIns="45720" tIns="27432" rIns="45720" bIns="27432" anchor="t">
             <a:spAutoFit/>
           </a:bodyPr>
           <a:lstStyle/>
@@ -14791,6 +15002,7 @@
           <a:lstStyle/>
           <a:p>
             <a:pPr algn="ctr"/>
+            <a:endParaRPr/>
           </a:p>
         </p:txBody>
       </p:sp>
@@ -14835,6 +15047,7 @@
           <a:lstStyle/>
           <a:p>
             <a:pPr algn="ctr"/>
+            <a:endParaRPr/>
           </a:p>
         </p:txBody>
       </p:sp>
@@ -14855,7 +15068,7 @@
           <a:noFill/>
         </p:spPr>
         <p:txBody>
-          <a:bodyPr wrap="square" anchor="ctr" lIns="45720" rIns="45720" tIns="27432" bIns="27432">
+          <a:bodyPr wrap="square" lIns="45720" tIns="27432" rIns="45720" bIns="27432" anchor="ctr">
             <a:spAutoFit/>
           </a:bodyPr>
           <a:lstStyle/>
@@ -14894,7 +15107,7 @@
           <a:noFill/>
         </p:spPr>
         <p:txBody>
-          <a:bodyPr wrap="square" anchor="t" lIns="45720" rIns="45720" tIns="27432" bIns="27432">
+          <a:bodyPr wrap="square" lIns="45720" tIns="27432" rIns="45720" bIns="27432" anchor="t">
             <a:spAutoFit/>
           </a:bodyPr>
           <a:lstStyle/>
@@ -14933,7 +15146,7 @@
           <a:noFill/>
         </p:spPr>
         <p:txBody>
-          <a:bodyPr wrap="square" anchor="t" lIns="45720" rIns="45720" tIns="27432" bIns="27432">
+          <a:bodyPr wrap="square" lIns="45720" tIns="27432" rIns="45720" bIns="27432" anchor="t">
             <a:spAutoFit/>
           </a:bodyPr>
           <a:lstStyle/>
@@ -14972,7 +15185,7 @@
           <a:noFill/>
         </p:spPr>
         <p:txBody>
-          <a:bodyPr wrap="square" anchor="t" lIns="45720" rIns="45720" tIns="27432" bIns="27432">
+          <a:bodyPr wrap="square" lIns="45720" tIns="27432" rIns="45720" bIns="27432" anchor="t">
             <a:spAutoFit/>
           </a:bodyPr>
           <a:lstStyle/>
@@ -15011,7 +15224,7 @@
           <a:noFill/>
         </p:spPr>
         <p:txBody>
-          <a:bodyPr wrap="square" anchor="t" lIns="45720" rIns="45720" tIns="27432" bIns="27432">
+          <a:bodyPr wrap="square" lIns="45720" tIns="27432" rIns="45720" bIns="27432" anchor="t">
             <a:spAutoFit/>
           </a:bodyPr>
           <a:lstStyle/>
@@ -15050,7 +15263,7 @@
           <a:noFill/>
         </p:spPr>
         <p:txBody>
-          <a:bodyPr wrap="square" anchor="t" lIns="45720" rIns="45720" tIns="27432" bIns="27432">
+          <a:bodyPr wrap="square" lIns="45720" tIns="27432" rIns="45720" bIns="27432" anchor="t">
             <a:spAutoFit/>
           </a:bodyPr>
           <a:lstStyle/>
@@ -15081,7 +15294,7 @@
 </file>
 
 <file path=ppt/slides/slide4.xml><?xml version="1.0" encoding="utf-8"?>
-<p:sld xmlns:a="http://schemas.openxmlformats.org/drawingml/2006/main" xmlns:p="http://schemas.openxmlformats.org/presentationml/2006/main" xmlns:r="http://schemas.openxmlformats.org/officeDocument/2006/relationships">
+<p:sld xmlns:a="http://schemas.openxmlformats.org/drawingml/2006/main" xmlns:r="http://schemas.openxmlformats.org/officeDocument/2006/relationships" xmlns:p="http://schemas.openxmlformats.org/presentationml/2006/main">
   <p:cSld>
     <p:spTree>
       <p:nvGrpSpPr>
@@ -15089,7 +15302,14 @@
         <p:cNvGrpSpPr/>
         <p:nvPr/>
       </p:nvGrpSpPr>
-      <p:grpSpPr/>
+      <p:grpSpPr>
+        <a:xfrm>
+          <a:off x="0" y="0"/>
+          <a:ext cx="0" cy="0"/>
+          <a:chOff x="0" y="0"/>
+          <a:chExt cx="0" cy="0"/>
+        </a:xfrm>
+      </p:grpSpPr>
       <p:sp>
         <p:nvSpPr>
           <p:cNvPr id="2" name="Rectangle 1"/>
@@ -15131,6 +15351,7 @@
           <a:lstStyle/>
           <a:p>
             <a:pPr algn="ctr"/>
+            <a:endParaRPr/>
           </a:p>
         </p:txBody>
       </p:sp>
@@ -15175,6 +15396,7 @@
           <a:lstStyle/>
           <a:p>
             <a:pPr algn="ctr"/>
+            <a:endParaRPr/>
           </a:p>
         </p:txBody>
       </p:sp>
@@ -15221,6 +15443,7 @@
           <a:lstStyle/>
           <a:p>
             <a:pPr algn="ctr"/>
+            <a:endParaRPr/>
           </a:p>
         </p:txBody>
       </p:sp>
@@ -15241,7 +15464,7 @@
           <a:noFill/>
         </p:spPr>
         <p:txBody>
-          <a:bodyPr wrap="square" anchor="ctr" lIns="45720" rIns="45720" tIns="27432" bIns="27432">
+          <a:bodyPr wrap="square" lIns="45720" tIns="27432" rIns="45720" bIns="27432" anchor="ctr">
             <a:spAutoFit/>
           </a:bodyPr>
           <a:lstStyle/>
@@ -15280,7 +15503,7 @@
           <a:noFill/>
         </p:spPr>
         <p:txBody>
-          <a:bodyPr wrap="square" anchor="ctr" lIns="45720" rIns="45720" tIns="27432" bIns="27432">
+          <a:bodyPr wrap="square" lIns="45720" tIns="27432" rIns="45720" bIns="27432" anchor="ctr">
             <a:spAutoFit/>
           </a:bodyPr>
           <a:lstStyle/>
@@ -15310,16 +15533,15 @@
           </p:cNvPicPr>
           <p:nvPr/>
         </p:nvPicPr>
-        <p:blipFill>
+        <p:blipFill rotWithShape="1">
           <a:blip r:embed="rId2"/>
-          <a:stretch>
-            <a:fillRect/>
-          </a:stretch>
+          <a:srcRect l="-543" b="6124"/>
+          <a:stretch/>
         </p:blipFill>
         <p:spPr>
           <a:xfrm>
-            <a:off x="411480" y="1188720"/>
-            <a:ext cx="7772400" cy="4371975"/>
+            <a:off x="369277" y="1188720"/>
+            <a:ext cx="7814603" cy="4104249"/>
           </a:xfrm>
           <a:prstGeom prst="rect">
             <a:avLst/>
@@ -15367,6 +15589,7 @@
           <a:lstStyle/>
           <a:p>
             <a:pPr algn="ctr"/>
+            <a:endParaRPr/>
           </a:p>
         </p:txBody>
       </p:sp>
@@ -15378,7 +15601,7 @@
         </p:nvSpPr>
         <p:spPr>
           <a:xfrm>
-            <a:off x="411480" y="5597271"/>
+            <a:off x="390378" y="5289672"/>
             <a:ext cx="7772400" cy="274320"/>
           </a:xfrm>
           <a:prstGeom prst="rect">
@@ -15387,7 +15610,7 @@
           <a:noFill/>
         </p:spPr>
         <p:txBody>
-          <a:bodyPr wrap="square" anchor="t" lIns="45720" rIns="45720" tIns="27432" bIns="27432">
+          <a:bodyPr wrap="square" lIns="45720" tIns="27432" rIns="45720" bIns="27432" anchor="t">
             <a:spAutoFit/>
           </a:bodyPr>
           <a:lstStyle/>
@@ -15398,14 +15621,146 @@
               </a:lnSpc>
             </a:pPr>
             <a:r>
-              <a:rPr sz="1100" b="0" i="0">
+              <a:rPr sz="1100" b="0" i="0" dirty="0" err="1">
                 <a:solidFill>
                   <a:srgbClr val="5B6675"/>
                 </a:solidFill>
                 <a:latin typeface="Calibri"/>
               </a:rPr>
-              <a:t>Рис. 1. Добавление журнала Defender в ossec.conf агента и перезапуск службы Wazuh</a:t>
-            </a:r>
+              <a:t>Рис</a:t>
+            </a:r>
+            <a:r>
+              <a:rPr sz="1100" b="0" i="0" dirty="0">
+                <a:solidFill>
+                  <a:srgbClr val="5B6675"/>
+                </a:solidFill>
+                <a:latin typeface="Calibri"/>
+              </a:rPr>
+              <a:t>. 1. </a:t>
+            </a:r>
+            <a:r>
+              <a:rPr sz="1100" b="0" i="0" dirty="0" err="1">
+                <a:solidFill>
+                  <a:srgbClr val="5B6675"/>
+                </a:solidFill>
+                <a:latin typeface="Calibri"/>
+              </a:rPr>
+              <a:t>Добавление</a:t>
+            </a:r>
+            <a:r>
+              <a:rPr sz="1100" b="0" i="0" dirty="0">
+                <a:solidFill>
+                  <a:srgbClr val="5B6675"/>
+                </a:solidFill>
+                <a:latin typeface="Calibri"/>
+              </a:rPr>
+              <a:t> </a:t>
+            </a:r>
+            <a:r>
+              <a:rPr sz="1100" b="0" i="0" dirty="0" err="1">
+                <a:solidFill>
+                  <a:srgbClr val="5B6675"/>
+                </a:solidFill>
+                <a:latin typeface="Calibri"/>
+              </a:rPr>
+              <a:t>журнала</a:t>
+            </a:r>
+            <a:r>
+              <a:rPr sz="1100" b="0" i="0" dirty="0">
+                <a:solidFill>
+                  <a:srgbClr val="5B6675"/>
+                </a:solidFill>
+                <a:latin typeface="Calibri"/>
+              </a:rPr>
+              <a:t> Defender в </a:t>
+            </a:r>
+            <a:r>
+              <a:rPr sz="1100" b="0" i="0" dirty="0" err="1">
+                <a:solidFill>
+                  <a:srgbClr val="5B6675"/>
+                </a:solidFill>
+                <a:latin typeface="Calibri"/>
+              </a:rPr>
+              <a:t>ossec.conf</a:t>
+            </a:r>
+            <a:r>
+              <a:rPr sz="1100" b="0" i="0" dirty="0">
+                <a:solidFill>
+                  <a:srgbClr val="5B6675"/>
+                </a:solidFill>
+                <a:latin typeface="Calibri"/>
+              </a:rPr>
+              <a:t> </a:t>
+            </a:r>
+            <a:r>
+              <a:rPr sz="1100" b="0" i="0" dirty="0" err="1">
+                <a:solidFill>
+                  <a:srgbClr val="5B6675"/>
+                </a:solidFill>
+                <a:latin typeface="Calibri"/>
+              </a:rPr>
+              <a:t>агента</a:t>
+            </a:r>
+            <a:r>
+              <a:rPr sz="1100" b="0" i="0" dirty="0">
+                <a:solidFill>
+                  <a:srgbClr val="5B6675"/>
+                </a:solidFill>
+                <a:latin typeface="Calibri"/>
+              </a:rPr>
+              <a:t> и </a:t>
+            </a:r>
+            <a:r>
+              <a:rPr sz="1100" b="0" i="0" dirty="0" err="1">
+                <a:solidFill>
+                  <a:srgbClr val="5B6675"/>
+                </a:solidFill>
+                <a:latin typeface="Calibri"/>
+              </a:rPr>
+              <a:t>перезапуск</a:t>
+            </a:r>
+            <a:r>
+              <a:rPr sz="1100" b="0" i="0" dirty="0">
+                <a:solidFill>
+                  <a:srgbClr val="5B6675"/>
+                </a:solidFill>
+                <a:latin typeface="Calibri"/>
+              </a:rPr>
+              <a:t> </a:t>
+            </a:r>
+            <a:r>
+              <a:rPr sz="1100" b="0" i="0" dirty="0" err="1">
+                <a:solidFill>
+                  <a:srgbClr val="5B6675"/>
+                </a:solidFill>
+                <a:latin typeface="Calibri"/>
+              </a:rPr>
+              <a:t>службы</a:t>
+            </a:r>
+            <a:r>
+              <a:rPr sz="1100" b="0" i="0" dirty="0">
+                <a:solidFill>
+                  <a:srgbClr val="5B6675"/>
+                </a:solidFill>
+                <a:latin typeface="Calibri"/>
+              </a:rPr>
+              <a:t> </a:t>
+            </a:r>
+            <a:r>
+              <a:rPr sz="1100" b="0" i="0" dirty="0" err="1">
+                <a:solidFill>
+                  <a:srgbClr val="5B6675"/>
+                </a:solidFill>
+                <a:latin typeface="Calibri"/>
+              </a:rPr>
+              <a:t>Wazuh</a:t>
+            </a:r>
+            <a:endParaRPr sz="1100" b="0" i="0" dirty="0">
+              <a:solidFill>
+                <a:srgbClr val="5B6675"/>
+              </a:solidFill>
+              <a:latin typeface="Calibri"/>
+            </a:endParaRPr>
           </a:p>
         </p:txBody>
       </p:sp>
@@ -15450,6 +15805,7 @@
           <a:lstStyle/>
           <a:p>
             <a:pPr algn="ctr"/>
+            <a:endParaRPr/>
           </a:p>
         </p:txBody>
       </p:sp>
@@ -15494,6 +15850,7 @@
           <a:lstStyle/>
           <a:p>
             <a:pPr algn="ctr"/>
+            <a:endParaRPr/>
           </a:p>
         </p:txBody>
       </p:sp>
@@ -15514,7 +15871,7 @@
           <a:noFill/>
         </p:spPr>
         <p:txBody>
-          <a:bodyPr wrap="square" anchor="t" lIns="45720" rIns="45720" tIns="27432" bIns="27432">
+          <a:bodyPr wrap="square" lIns="45720" tIns="27432" rIns="45720" bIns="27432" anchor="t">
             <a:spAutoFit/>
           </a:bodyPr>
           <a:lstStyle/>
@@ -15577,6 +15934,7 @@
           <a:lstStyle/>
           <a:p>
             <a:pPr algn="ctr"/>
+            <a:endParaRPr/>
           </a:p>
         </p:txBody>
       </p:sp>
@@ -15597,7 +15955,7 @@
           <a:noFill/>
         </p:spPr>
         <p:txBody>
-          <a:bodyPr wrap="square" anchor="ctr" lIns="45720" rIns="45720" tIns="27432" bIns="27432">
+          <a:bodyPr wrap="square" lIns="45720" tIns="27432" rIns="45720" bIns="27432" anchor="ctr">
             <a:spAutoFit/>
           </a:bodyPr>
           <a:lstStyle/>
@@ -15636,7 +15994,7 @@
           <a:noFill/>
         </p:spPr>
         <p:txBody>
-          <a:bodyPr wrap="square" anchor="ctr" lIns="45720" rIns="45720" tIns="27432" bIns="27432">
+          <a:bodyPr wrap="square" lIns="45720" tIns="27432" rIns="45720" bIns="27432" anchor="ctr">
             <a:spAutoFit/>
           </a:bodyPr>
           <a:lstStyle/>
@@ -15699,6 +16057,7 @@
           <a:lstStyle/>
           <a:p>
             <a:pPr algn="ctr"/>
+            <a:endParaRPr/>
           </a:p>
         </p:txBody>
       </p:sp>
@@ -15719,7 +16078,7 @@
           <a:noFill/>
         </p:spPr>
         <p:txBody>
-          <a:bodyPr wrap="square" anchor="ctr" lIns="45720" rIns="45720" tIns="27432" bIns="27432">
+          <a:bodyPr wrap="square" lIns="45720" tIns="27432" rIns="45720" bIns="27432" anchor="ctr">
             <a:spAutoFit/>
           </a:bodyPr>
           <a:lstStyle/>
@@ -15758,7 +16117,7 @@
           <a:noFill/>
         </p:spPr>
         <p:txBody>
-          <a:bodyPr wrap="square" anchor="ctr" lIns="45720" rIns="45720" tIns="27432" bIns="27432">
+          <a:bodyPr wrap="square" lIns="45720" tIns="27432" rIns="45720" bIns="27432" anchor="ctr">
             <a:spAutoFit/>
           </a:bodyPr>
           <a:lstStyle/>
@@ -15821,6 +16180,7 @@
           <a:lstStyle/>
           <a:p>
             <a:pPr algn="ctr"/>
+            <a:endParaRPr/>
           </a:p>
         </p:txBody>
       </p:sp>
@@ -15841,7 +16201,7 @@
           <a:noFill/>
         </p:spPr>
         <p:txBody>
-          <a:bodyPr wrap="square" anchor="ctr" lIns="45720" rIns="45720" tIns="27432" bIns="27432">
+          <a:bodyPr wrap="square" lIns="45720" tIns="27432" rIns="45720" bIns="27432" anchor="ctr">
             <a:spAutoFit/>
           </a:bodyPr>
           <a:lstStyle/>
@@ -15880,7 +16240,7 @@
           <a:noFill/>
         </p:spPr>
         <p:txBody>
-          <a:bodyPr wrap="square" anchor="ctr" lIns="45720" rIns="45720" tIns="27432" bIns="27432">
+          <a:bodyPr wrap="square" lIns="45720" tIns="27432" rIns="45720" bIns="27432" anchor="ctr">
             <a:spAutoFit/>
           </a:bodyPr>
           <a:lstStyle/>
@@ -15943,6 +16303,7 @@
           <a:lstStyle/>
           <a:p>
             <a:pPr algn="ctr"/>
+            <a:endParaRPr/>
           </a:p>
         </p:txBody>
       </p:sp>
@@ -15963,7 +16324,7 @@
           <a:noFill/>
         </p:spPr>
         <p:txBody>
-          <a:bodyPr wrap="square" anchor="ctr" lIns="45720" rIns="45720" tIns="27432" bIns="27432">
+          <a:bodyPr wrap="square" lIns="45720" tIns="27432" rIns="45720" bIns="27432" anchor="ctr">
             <a:spAutoFit/>
           </a:bodyPr>
           <a:lstStyle/>
@@ -16002,7 +16363,7 @@
           <a:noFill/>
         </p:spPr>
         <p:txBody>
-          <a:bodyPr wrap="square" anchor="ctr" lIns="45720" rIns="45720" tIns="27432" bIns="27432">
+          <a:bodyPr wrap="square" lIns="45720" tIns="27432" rIns="45720" bIns="27432" anchor="ctr">
             <a:spAutoFit/>
           </a:bodyPr>
           <a:lstStyle/>
@@ -16065,6 +16426,7 @@
           <a:lstStyle/>
           <a:p>
             <a:pPr algn="ctr"/>
+            <a:endParaRPr/>
           </a:p>
         </p:txBody>
       </p:sp>
@@ -16085,7 +16447,7 @@
           <a:noFill/>
         </p:spPr>
         <p:txBody>
-          <a:bodyPr wrap="square" anchor="ctr" lIns="45720" rIns="45720" tIns="27432" bIns="27432">
+          <a:bodyPr wrap="square" lIns="45720" tIns="27432" rIns="45720" bIns="27432" anchor="ctr">
             <a:spAutoFit/>
           </a:bodyPr>
           <a:lstStyle/>
@@ -16124,7 +16486,7 @@
           <a:noFill/>
         </p:spPr>
         <p:txBody>
-          <a:bodyPr wrap="square" anchor="ctr" lIns="45720" rIns="45720" tIns="27432" bIns="27432">
+          <a:bodyPr wrap="square" lIns="45720" tIns="27432" rIns="45720" bIns="27432" anchor="ctr">
             <a:spAutoFit/>
           </a:bodyPr>
           <a:lstStyle/>
@@ -16187,6 +16549,7 @@
           <a:lstStyle/>
           <a:p>
             <a:pPr algn="ctr"/>
+            <a:endParaRPr/>
           </a:p>
         </p:txBody>
       </p:sp>
@@ -16207,7 +16570,7 @@
           <a:noFill/>
         </p:spPr>
         <p:txBody>
-          <a:bodyPr wrap="square" anchor="ctr" lIns="45720" rIns="45720" tIns="27432" bIns="27432">
+          <a:bodyPr wrap="square" lIns="45720" tIns="27432" rIns="45720" bIns="27432" anchor="ctr">
             <a:spAutoFit/>
           </a:bodyPr>
           <a:lstStyle/>
@@ -16246,7 +16609,7 @@
           <a:noFill/>
         </p:spPr>
         <p:txBody>
-          <a:bodyPr wrap="square" anchor="ctr" lIns="45720" rIns="45720" tIns="27432" bIns="27432">
+          <a:bodyPr wrap="square" lIns="45720" tIns="27432" rIns="45720" bIns="27432" anchor="ctr">
             <a:spAutoFit/>
           </a:bodyPr>
           <a:lstStyle/>
@@ -16285,7 +16648,7 @@
           <a:noFill/>
         </p:spPr>
         <p:txBody>
-          <a:bodyPr wrap="square" anchor="t" lIns="45720" rIns="45720" tIns="27432" bIns="27432">
+          <a:bodyPr wrap="square" lIns="45720" tIns="27432" rIns="45720" bIns="27432" anchor="t">
             <a:spAutoFit/>
           </a:bodyPr>
           <a:lstStyle/>
@@ -16324,7 +16687,7 @@
           <a:noFill/>
         </p:spPr>
         <p:txBody>
-          <a:bodyPr wrap="square" anchor="t" lIns="45720" rIns="45720" tIns="27432" bIns="27432">
+          <a:bodyPr wrap="square" lIns="45720" tIns="27432" rIns="45720" bIns="27432" anchor="t">
             <a:spAutoFit/>
           </a:bodyPr>
           <a:lstStyle/>
@@ -16363,7 +16726,7 @@
           <a:noFill/>
         </p:spPr>
         <p:txBody>
-          <a:bodyPr wrap="square" anchor="t" lIns="45720" rIns="45720" tIns="27432" bIns="27432">
+          <a:bodyPr wrap="square" lIns="45720" tIns="27432" rIns="45720" bIns="27432" anchor="t">
             <a:spAutoFit/>
           </a:bodyPr>
           <a:lstStyle/>
@@ -16394,7 +16757,7 @@
 </file>
 
 <file path=ppt/slides/slide5.xml><?xml version="1.0" encoding="utf-8"?>
-<p:sld xmlns:a="http://schemas.openxmlformats.org/drawingml/2006/main" xmlns:p="http://schemas.openxmlformats.org/presentationml/2006/main" xmlns:r="http://schemas.openxmlformats.org/officeDocument/2006/relationships">
+<p:sld xmlns:a="http://schemas.openxmlformats.org/drawingml/2006/main" xmlns:r="http://schemas.openxmlformats.org/officeDocument/2006/relationships" xmlns:p="http://schemas.openxmlformats.org/presentationml/2006/main">
   <p:cSld>
     <p:spTree>
       <p:nvGrpSpPr>
@@ -16402,7 +16765,14 @@
         <p:cNvGrpSpPr/>
         <p:nvPr/>
       </p:nvGrpSpPr>
-      <p:grpSpPr/>
+      <p:grpSpPr>
+        <a:xfrm>
+          <a:off x="0" y="0"/>
+          <a:ext cx="0" cy="0"/>
+          <a:chOff x="0" y="0"/>
+          <a:chExt cx="0" cy="0"/>
+        </a:xfrm>
+      </p:grpSpPr>
       <p:sp>
         <p:nvSpPr>
           <p:cNvPr id="2" name="Rectangle 1"/>
@@ -16444,6 +16814,7 @@
           <a:lstStyle/>
           <a:p>
             <a:pPr algn="ctr"/>
+            <a:endParaRPr/>
           </a:p>
         </p:txBody>
       </p:sp>
@@ -16488,6 +16859,7 @@
           <a:lstStyle/>
           <a:p>
             <a:pPr algn="ctr"/>
+            <a:endParaRPr/>
           </a:p>
         </p:txBody>
       </p:sp>
@@ -16534,6 +16906,7 @@
           <a:lstStyle/>
           <a:p>
             <a:pPr algn="ctr"/>
+            <a:endParaRPr/>
           </a:p>
         </p:txBody>
       </p:sp>
@@ -16554,7 +16927,7 @@
           <a:noFill/>
         </p:spPr>
         <p:txBody>
-          <a:bodyPr wrap="square" anchor="ctr" lIns="45720" rIns="45720" tIns="27432" bIns="27432">
+          <a:bodyPr wrap="square" lIns="45720" tIns="27432" rIns="45720" bIns="27432" anchor="ctr">
             <a:spAutoFit/>
           </a:bodyPr>
           <a:lstStyle/>
@@ -16593,7 +16966,7 @@
           <a:noFill/>
         </p:spPr>
         <p:txBody>
-          <a:bodyPr wrap="square" anchor="ctr" lIns="45720" rIns="45720" tIns="27432" bIns="27432">
+          <a:bodyPr wrap="square" lIns="45720" tIns="27432" rIns="45720" bIns="27432" anchor="ctr">
             <a:spAutoFit/>
           </a:bodyPr>
           <a:lstStyle/>
@@ -16680,6 +17053,7 @@
           <a:lstStyle/>
           <a:p>
             <a:pPr algn="ctr"/>
+            <a:endParaRPr/>
           </a:p>
         </p:txBody>
       </p:sp>
@@ -16700,7 +17074,7 @@
           <a:noFill/>
         </p:spPr>
         <p:txBody>
-          <a:bodyPr wrap="square" anchor="t" lIns="45720" rIns="45720" tIns="27432" bIns="27432">
+          <a:bodyPr wrap="square" lIns="45720" tIns="27432" rIns="45720" bIns="27432" anchor="t">
             <a:spAutoFit/>
           </a:bodyPr>
           <a:lstStyle/>
@@ -16763,6 +17137,7 @@
           <a:lstStyle/>
           <a:p>
             <a:pPr algn="ctr"/>
+            <a:endParaRPr/>
           </a:p>
         </p:txBody>
       </p:sp>
@@ -16807,6 +17182,7 @@
           <a:lstStyle/>
           <a:p>
             <a:pPr algn="ctr"/>
+            <a:endParaRPr/>
           </a:p>
         </p:txBody>
       </p:sp>
@@ -16827,7 +17203,7 @@
           <a:noFill/>
         </p:spPr>
         <p:txBody>
-          <a:bodyPr wrap="square" anchor="t" lIns="45720" rIns="45720" tIns="27432" bIns="27432">
+          <a:bodyPr wrap="square" lIns="45720" tIns="27432" rIns="45720" bIns="27432" anchor="t">
             <a:spAutoFit/>
           </a:bodyPr>
           <a:lstStyle/>
@@ -16866,7 +17242,7 @@
           <a:noFill/>
         </p:spPr>
         <p:txBody>
-          <a:bodyPr wrap="square" anchor="t" lIns="45720" rIns="45720" tIns="27432" bIns="27432">
+          <a:bodyPr wrap="square" lIns="45720" tIns="27432" rIns="45720" bIns="27432" anchor="t">
             <a:spAutoFit/>
           </a:bodyPr>
           <a:lstStyle/>
@@ -17093,7 +17469,7 @@
           <a:noFill/>
         </p:spPr>
         <p:txBody>
-          <a:bodyPr wrap="square" anchor="t" lIns="45720" rIns="45720" tIns="27432" bIns="27432">
+          <a:bodyPr wrap="square" lIns="45720" tIns="27432" rIns="45720" bIns="27432" anchor="t">
             <a:spAutoFit/>
           </a:bodyPr>
           <a:lstStyle/>
@@ -17132,7 +17508,7 @@
           <a:noFill/>
         </p:spPr>
         <p:txBody>
-          <a:bodyPr wrap="square" anchor="t" lIns="45720" rIns="45720" tIns="27432" bIns="27432">
+          <a:bodyPr wrap="square" lIns="45720" tIns="27432" rIns="45720" bIns="27432" anchor="t">
             <a:spAutoFit/>
           </a:bodyPr>
           <a:lstStyle/>
@@ -17163,7 +17539,7 @@
 </file>
 
 <file path=ppt/slides/slide6.xml><?xml version="1.0" encoding="utf-8"?>
-<p:sld xmlns:a="http://schemas.openxmlformats.org/drawingml/2006/main" xmlns:p="http://schemas.openxmlformats.org/presentationml/2006/main" xmlns:r="http://schemas.openxmlformats.org/officeDocument/2006/relationships">
+<p:sld xmlns:a="http://schemas.openxmlformats.org/drawingml/2006/main" xmlns:r="http://schemas.openxmlformats.org/officeDocument/2006/relationships" xmlns:p="http://schemas.openxmlformats.org/presentationml/2006/main">
   <p:cSld>
     <p:spTree>
       <p:nvGrpSpPr>
@@ -17171,7 +17547,14 @@
         <p:cNvGrpSpPr/>
         <p:nvPr/>
       </p:nvGrpSpPr>
-      <p:grpSpPr/>
+      <p:grpSpPr>
+        <a:xfrm>
+          <a:off x="0" y="0"/>
+          <a:ext cx="0" cy="0"/>
+          <a:chOff x="0" y="0"/>
+          <a:chExt cx="0" cy="0"/>
+        </a:xfrm>
+      </p:grpSpPr>
       <p:sp>
         <p:nvSpPr>
           <p:cNvPr id="2" name="Rectangle 1"/>
@@ -17213,6 +17596,7 @@
           <a:lstStyle/>
           <a:p>
             <a:pPr algn="ctr"/>
+            <a:endParaRPr/>
           </a:p>
         </p:txBody>
       </p:sp>
@@ -17257,6 +17641,7 @@
           <a:lstStyle/>
           <a:p>
             <a:pPr algn="ctr"/>
+            <a:endParaRPr/>
           </a:p>
         </p:txBody>
       </p:sp>
@@ -17303,6 +17688,7 @@
           <a:lstStyle/>
           <a:p>
             <a:pPr algn="ctr"/>
+            <a:endParaRPr/>
           </a:p>
         </p:txBody>
       </p:sp>
@@ -17323,7 +17709,7 @@
           <a:noFill/>
         </p:spPr>
         <p:txBody>
-          <a:bodyPr wrap="square" anchor="ctr" lIns="45720" rIns="45720" tIns="27432" bIns="27432">
+          <a:bodyPr wrap="square" lIns="45720" tIns="27432" rIns="45720" bIns="27432" anchor="ctr">
             <a:spAutoFit/>
           </a:bodyPr>
           <a:lstStyle/>
@@ -17362,7 +17748,7 @@
           <a:noFill/>
         </p:spPr>
         <p:txBody>
-          <a:bodyPr wrap="square" anchor="ctr" lIns="45720" rIns="45720" tIns="27432" bIns="27432">
+          <a:bodyPr wrap="square" lIns="45720" tIns="27432" rIns="45720" bIns="27432" anchor="ctr">
             <a:spAutoFit/>
           </a:bodyPr>
           <a:lstStyle/>
@@ -17449,6 +17835,7 @@
           <a:lstStyle/>
           <a:p>
             <a:pPr algn="ctr"/>
+            <a:endParaRPr/>
           </a:p>
         </p:txBody>
       </p:sp>
@@ -17469,7 +17856,7 @@
           <a:noFill/>
         </p:spPr>
         <p:txBody>
-          <a:bodyPr wrap="square" anchor="t" lIns="45720" rIns="45720" tIns="27432" bIns="27432">
+          <a:bodyPr wrap="square" lIns="45720" tIns="27432" rIns="45720" bIns="27432" anchor="t">
             <a:spAutoFit/>
           </a:bodyPr>
           <a:lstStyle/>
@@ -17532,6 +17919,7 @@
           <a:lstStyle/>
           <a:p>
             <a:pPr algn="ctr"/>
+            <a:endParaRPr/>
           </a:p>
         </p:txBody>
       </p:sp>
@@ -17576,6 +17964,7 @@
           <a:lstStyle/>
           <a:p>
             <a:pPr algn="ctr"/>
+            <a:endParaRPr/>
           </a:p>
         </p:txBody>
       </p:sp>
@@ -17596,7 +17985,7 @@
           <a:noFill/>
         </p:spPr>
         <p:txBody>
-          <a:bodyPr wrap="square" anchor="t" lIns="45720" rIns="45720" tIns="27432" bIns="27432">
+          <a:bodyPr wrap="square" lIns="45720" tIns="27432" rIns="45720" bIns="27432" anchor="t">
             <a:spAutoFit/>
           </a:bodyPr>
           <a:lstStyle/>
@@ -17635,7 +18024,7 @@
           <a:noFill/>
         </p:spPr>
         <p:txBody>
-          <a:bodyPr wrap="square" anchor="t" lIns="45720" rIns="45720" tIns="27432" bIns="27432">
+          <a:bodyPr wrap="square" lIns="45720" tIns="27432" rIns="45720" bIns="27432" anchor="t">
             <a:spAutoFit/>
           </a:bodyPr>
           <a:lstStyle/>
@@ -17871,7 +18260,7 @@
           <a:noFill/>
         </p:spPr>
         <p:txBody>
-          <a:bodyPr wrap="square" anchor="t" lIns="45720" rIns="45720" tIns="27432" bIns="27432">
+          <a:bodyPr wrap="square" lIns="45720" tIns="27432" rIns="45720" bIns="27432" anchor="t">
             <a:spAutoFit/>
           </a:bodyPr>
           <a:lstStyle/>
@@ -17910,7 +18299,7 @@
           <a:noFill/>
         </p:spPr>
         <p:txBody>
-          <a:bodyPr wrap="square" anchor="t" lIns="45720" rIns="45720" tIns="27432" bIns="27432">
+          <a:bodyPr wrap="square" lIns="45720" tIns="27432" rIns="45720" bIns="27432" anchor="t">
             <a:spAutoFit/>
           </a:bodyPr>
           <a:lstStyle/>
@@ -17941,7 +18330,7 @@
 </file>
 
 <file path=ppt/slides/slide7.xml><?xml version="1.0" encoding="utf-8"?>
-<p:sld xmlns:a="http://schemas.openxmlformats.org/drawingml/2006/main" xmlns:p="http://schemas.openxmlformats.org/presentationml/2006/main" xmlns:r="http://schemas.openxmlformats.org/officeDocument/2006/relationships">
+<p:sld xmlns:a="http://schemas.openxmlformats.org/drawingml/2006/main" xmlns:r="http://schemas.openxmlformats.org/officeDocument/2006/relationships" xmlns:p="http://schemas.openxmlformats.org/presentationml/2006/main">
   <p:cSld>
     <p:spTree>
       <p:nvGrpSpPr>
@@ -17949,7 +18338,14 @@
         <p:cNvGrpSpPr/>
         <p:nvPr/>
       </p:nvGrpSpPr>
-      <p:grpSpPr/>
+      <p:grpSpPr>
+        <a:xfrm>
+          <a:off x="0" y="0"/>
+          <a:ext cx="0" cy="0"/>
+          <a:chOff x="0" y="0"/>
+          <a:chExt cx="0" cy="0"/>
+        </a:xfrm>
+      </p:grpSpPr>
       <p:sp>
         <p:nvSpPr>
           <p:cNvPr id="2" name="Rectangle 1"/>
@@ -17991,6 +18387,7 @@
           <a:lstStyle/>
           <a:p>
             <a:pPr algn="ctr"/>
+            <a:endParaRPr/>
           </a:p>
         </p:txBody>
       </p:sp>
@@ -18035,6 +18432,7 @@
           <a:lstStyle/>
           <a:p>
             <a:pPr algn="ctr"/>
+            <a:endParaRPr/>
           </a:p>
         </p:txBody>
       </p:sp>
@@ -18081,6 +18479,7 @@
           <a:lstStyle/>
           <a:p>
             <a:pPr algn="ctr"/>
+            <a:endParaRPr/>
           </a:p>
         </p:txBody>
       </p:sp>
@@ -18101,7 +18500,7 @@
           <a:noFill/>
         </p:spPr>
         <p:txBody>
-          <a:bodyPr wrap="square" anchor="ctr" lIns="45720" rIns="45720" tIns="27432" bIns="27432">
+          <a:bodyPr wrap="square" lIns="45720" tIns="27432" rIns="45720" bIns="27432" anchor="ctr">
             <a:spAutoFit/>
           </a:bodyPr>
           <a:lstStyle/>
@@ -18140,7 +18539,7 @@
           <a:noFill/>
         </p:spPr>
         <p:txBody>
-          <a:bodyPr wrap="square" anchor="ctr" lIns="45720" rIns="45720" tIns="27432" bIns="27432">
+          <a:bodyPr wrap="square" lIns="45720" tIns="27432" rIns="45720" bIns="27432" anchor="ctr">
             <a:spAutoFit/>
           </a:bodyPr>
           <a:lstStyle/>
@@ -18227,6 +18626,7 @@
           <a:lstStyle/>
           <a:p>
             <a:pPr algn="ctr"/>
+            <a:endParaRPr/>
           </a:p>
         </p:txBody>
       </p:sp>
@@ -18247,7 +18647,7 @@
           <a:noFill/>
         </p:spPr>
         <p:txBody>
-          <a:bodyPr wrap="square" anchor="t" lIns="45720" rIns="45720" tIns="27432" bIns="27432">
+          <a:bodyPr wrap="square" lIns="45720" tIns="27432" rIns="45720" bIns="27432" anchor="t">
             <a:spAutoFit/>
           </a:bodyPr>
           <a:lstStyle/>
@@ -18310,6 +18710,7 @@
           <a:lstStyle/>
           <a:p>
             <a:pPr algn="ctr"/>
+            <a:endParaRPr/>
           </a:p>
         </p:txBody>
       </p:sp>
@@ -18354,6 +18755,7 @@
           <a:lstStyle/>
           <a:p>
             <a:pPr algn="ctr"/>
+            <a:endParaRPr/>
           </a:p>
         </p:txBody>
       </p:sp>
@@ -18374,7 +18776,7 @@
           <a:noFill/>
         </p:spPr>
         <p:txBody>
-          <a:bodyPr wrap="square" anchor="t" lIns="45720" rIns="45720" tIns="27432" bIns="27432">
+          <a:bodyPr wrap="square" lIns="45720" tIns="27432" rIns="45720" bIns="27432" anchor="t">
             <a:spAutoFit/>
           </a:bodyPr>
           <a:lstStyle/>
@@ -18413,7 +18815,7 @@
           <a:noFill/>
         </p:spPr>
         <p:txBody>
-          <a:bodyPr wrap="square" anchor="t" lIns="45720" rIns="45720" tIns="27432" bIns="27432">
+          <a:bodyPr wrap="square" lIns="45720" tIns="27432" rIns="45720" bIns="27432" anchor="t">
             <a:spAutoFit/>
           </a:bodyPr>
           <a:lstStyle/>
@@ -18660,7 +19062,7 @@
           <a:noFill/>
         </p:spPr>
         <p:txBody>
-          <a:bodyPr wrap="square" anchor="t" lIns="45720" rIns="45720" tIns="27432" bIns="27432">
+          <a:bodyPr wrap="square" lIns="45720" tIns="27432" rIns="45720" bIns="27432" anchor="t">
             <a:spAutoFit/>
           </a:bodyPr>
           <a:lstStyle/>
@@ -18699,7 +19101,7 @@
           <a:noFill/>
         </p:spPr>
         <p:txBody>
-          <a:bodyPr wrap="square" anchor="t" lIns="45720" rIns="45720" tIns="27432" bIns="27432">
+          <a:bodyPr wrap="square" lIns="45720" tIns="27432" rIns="45720" bIns="27432" anchor="t">
             <a:spAutoFit/>
           </a:bodyPr>
           <a:lstStyle/>
@@ -18730,7 +19132,7 @@
 </file>
 
 <file path=ppt/slides/slide8.xml><?xml version="1.0" encoding="utf-8"?>
-<p:sld xmlns:a="http://schemas.openxmlformats.org/drawingml/2006/main" xmlns:p="http://schemas.openxmlformats.org/presentationml/2006/main" xmlns:r="http://schemas.openxmlformats.org/officeDocument/2006/relationships">
+<p:sld xmlns:a="http://schemas.openxmlformats.org/drawingml/2006/main" xmlns:r="http://schemas.openxmlformats.org/officeDocument/2006/relationships" xmlns:p="http://schemas.openxmlformats.org/presentationml/2006/main">
   <p:cSld>
     <p:spTree>
       <p:nvGrpSpPr>
@@ -18738,7 +19140,14 @@
         <p:cNvGrpSpPr/>
         <p:nvPr/>
       </p:nvGrpSpPr>
-      <p:grpSpPr/>
+      <p:grpSpPr>
+        <a:xfrm>
+          <a:off x="0" y="0"/>
+          <a:ext cx="0" cy="0"/>
+          <a:chOff x="0" y="0"/>
+          <a:chExt cx="0" cy="0"/>
+        </a:xfrm>
+      </p:grpSpPr>
       <p:sp>
         <p:nvSpPr>
           <p:cNvPr id="2" name="Rectangle 1"/>
@@ -18780,6 +19189,7 @@
           <a:lstStyle/>
           <a:p>
             <a:pPr algn="ctr"/>
+            <a:endParaRPr/>
           </a:p>
         </p:txBody>
       </p:sp>
@@ -18824,6 +19234,7 @@
           <a:lstStyle/>
           <a:p>
             <a:pPr algn="ctr"/>
+            <a:endParaRPr/>
           </a:p>
         </p:txBody>
       </p:sp>
@@ -18870,6 +19281,7 @@
           <a:lstStyle/>
           <a:p>
             <a:pPr algn="ctr"/>
+            <a:endParaRPr/>
           </a:p>
         </p:txBody>
       </p:sp>
@@ -18890,7 +19302,7 @@
           <a:noFill/>
         </p:spPr>
         <p:txBody>
-          <a:bodyPr wrap="square" anchor="ctr" lIns="45720" rIns="45720" tIns="27432" bIns="27432">
+          <a:bodyPr wrap="square" lIns="45720" tIns="27432" rIns="45720" bIns="27432" anchor="ctr">
             <a:spAutoFit/>
           </a:bodyPr>
           <a:lstStyle/>
@@ -18929,7 +19341,7 @@
           <a:noFill/>
         </p:spPr>
         <p:txBody>
-          <a:bodyPr wrap="square" anchor="ctr" lIns="45720" rIns="45720" tIns="27432" bIns="27432">
+          <a:bodyPr wrap="square" lIns="45720" tIns="27432" rIns="45720" bIns="27432" anchor="ctr">
             <a:spAutoFit/>
           </a:bodyPr>
           <a:lstStyle/>
@@ -19016,6 +19428,7 @@
           <a:lstStyle/>
           <a:p>
             <a:pPr algn="ctr"/>
+            <a:endParaRPr/>
           </a:p>
         </p:txBody>
       </p:sp>
@@ -19036,7 +19449,7 @@
           <a:noFill/>
         </p:spPr>
         <p:txBody>
-          <a:bodyPr wrap="square" anchor="t" lIns="45720" rIns="45720" tIns="27432" bIns="27432">
+          <a:bodyPr wrap="square" lIns="45720" tIns="27432" rIns="45720" bIns="27432" anchor="t">
             <a:spAutoFit/>
           </a:bodyPr>
           <a:lstStyle/>
@@ -19099,6 +19512,7 @@
           <a:lstStyle/>
           <a:p>
             <a:pPr algn="ctr"/>
+            <a:endParaRPr/>
           </a:p>
         </p:txBody>
       </p:sp>
@@ -19143,6 +19557,7 @@
           <a:lstStyle/>
           <a:p>
             <a:pPr algn="ctr"/>
+            <a:endParaRPr/>
           </a:p>
         </p:txBody>
       </p:sp>
@@ -19163,7 +19578,7 @@
           <a:noFill/>
         </p:spPr>
         <p:txBody>
-          <a:bodyPr wrap="square" anchor="t" lIns="45720" rIns="45720" tIns="27432" bIns="27432">
+          <a:bodyPr wrap="square" lIns="45720" tIns="27432" rIns="45720" bIns="27432" anchor="t">
             <a:spAutoFit/>
           </a:bodyPr>
           <a:lstStyle/>
@@ -19202,7 +19617,7 @@
           <a:noFill/>
         </p:spPr>
         <p:txBody>
-          <a:bodyPr wrap="square" anchor="t" lIns="45720" rIns="45720" tIns="27432" bIns="27432">
+          <a:bodyPr wrap="square" lIns="45720" tIns="27432" rIns="45720" bIns="27432" anchor="t">
             <a:spAutoFit/>
           </a:bodyPr>
           <a:lstStyle/>
@@ -19410,7 +19825,7 @@
           <a:noFill/>
         </p:spPr>
         <p:txBody>
-          <a:bodyPr wrap="square" anchor="t" lIns="45720" rIns="45720" tIns="27432" bIns="27432">
+          <a:bodyPr wrap="square" lIns="45720" tIns="27432" rIns="45720" bIns="27432" anchor="t">
             <a:spAutoFit/>
           </a:bodyPr>
           <a:lstStyle/>
@@ -19449,7 +19864,7 @@
           <a:noFill/>
         </p:spPr>
         <p:txBody>
-          <a:bodyPr wrap="square" anchor="t" lIns="45720" rIns="45720" tIns="27432" bIns="27432">
+          <a:bodyPr wrap="square" lIns="45720" tIns="27432" rIns="45720" bIns="27432" anchor="t">
             <a:spAutoFit/>
           </a:bodyPr>
           <a:lstStyle/>
@@ -19480,7 +19895,7 @@
 </file>
 
 <file path=ppt/slides/slide9.xml><?xml version="1.0" encoding="utf-8"?>
-<p:sld xmlns:a="http://schemas.openxmlformats.org/drawingml/2006/main" xmlns:p="http://schemas.openxmlformats.org/presentationml/2006/main" xmlns:r="http://schemas.openxmlformats.org/officeDocument/2006/relationships">
+<p:sld xmlns:a="http://schemas.openxmlformats.org/drawingml/2006/main" xmlns:r="http://schemas.openxmlformats.org/officeDocument/2006/relationships" xmlns:p="http://schemas.openxmlformats.org/presentationml/2006/main">
   <p:cSld>
     <p:spTree>
       <p:nvGrpSpPr>
@@ -19488,7 +19903,14 @@
         <p:cNvGrpSpPr/>
         <p:nvPr/>
       </p:nvGrpSpPr>
-      <p:grpSpPr/>
+      <p:grpSpPr>
+        <a:xfrm>
+          <a:off x="0" y="0"/>
+          <a:ext cx="0" cy="0"/>
+          <a:chOff x="0" y="0"/>
+          <a:chExt cx="0" cy="0"/>
+        </a:xfrm>
+      </p:grpSpPr>
       <p:sp>
         <p:nvSpPr>
           <p:cNvPr id="2" name="Rectangle 1"/>
@@ -19530,6 +19952,7 @@
           <a:lstStyle/>
           <a:p>
             <a:pPr algn="ctr"/>
+            <a:endParaRPr/>
           </a:p>
         </p:txBody>
       </p:sp>
@@ -19574,6 +19997,7 @@
           <a:lstStyle/>
           <a:p>
             <a:pPr algn="ctr"/>
+            <a:endParaRPr/>
           </a:p>
         </p:txBody>
       </p:sp>
@@ -19620,6 +20044,7 @@
           <a:lstStyle/>
           <a:p>
             <a:pPr algn="ctr"/>
+            <a:endParaRPr/>
           </a:p>
         </p:txBody>
       </p:sp>
@@ -19640,7 +20065,7 @@
           <a:noFill/>
         </p:spPr>
         <p:txBody>
-          <a:bodyPr wrap="square" anchor="ctr" lIns="45720" rIns="45720" tIns="27432" bIns="27432">
+          <a:bodyPr wrap="square" lIns="45720" tIns="27432" rIns="45720" bIns="27432" anchor="ctr">
             <a:spAutoFit/>
           </a:bodyPr>
           <a:lstStyle/>
@@ -19679,7 +20104,7 @@
           <a:noFill/>
         </p:spPr>
         <p:txBody>
-          <a:bodyPr wrap="square" anchor="ctr" lIns="45720" rIns="45720" tIns="27432" bIns="27432">
+          <a:bodyPr wrap="square" lIns="45720" tIns="27432" rIns="45720" bIns="27432" anchor="ctr">
             <a:spAutoFit/>
           </a:bodyPr>
           <a:lstStyle/>
@@ -19709,16 +20134,15 @@
           </p:cNvPicPr>
           <p:nvPr/>
         </p:nvPicPr>
-        <p:blipFill>
+        <p:blipFill rotWithShape="1">
           <a:blip r:embed="rId2"/>
-          <a:stretch>
-            <a:fillRect/>
-          </a:stretch>
+          <a:srcRect l="249" b="4112"/>
+          <a:stretch/>
         </p:blipFill>
         <p:spPr>
           <a:xfrm>
-            <a:off x="411480" y="1188720"/>
-            <a:ext cx="7772400" cy="4371975"/>
+            <a:off x="430822" y="1188721"/>
+            <a:ext cx="7753057" cy="4192172"/>
           </a:xfrm>
           <a:prstGeom prst="rect">
             <a:avLst/>
@@ -19766,6 +20190,7 @@
           <a:lstStyle/>
           <a:p>
             <a:pPr algn="ctr"/>
+            <a:endParaRPr/>
           </a:p>
         </p:txBody>
       </p:sp>
@@ -19777,7 +20202,7 @@
         </p:nvSpPr>
         <p:spPr>
           <a:xfrm>
-            <a:off x="411480" y="5597271"/>
+            <a:off x="411479" y="5337107"/>
             <a:ext cx="7772400" cy="274320"/>
           </a:xfrm>
           <a:prstGeom prst="rect">
@@ -19786,7 +20211,7 @@
           <a:noFill/>
         </p:spPr>
         <p:txBody>
-          <a:bodyPr wrap="square" anchor="t" lIns="45720" rIns="45720" tIns="27432" bIns="27432">
+          <a:bodyPr wrap="square" lIns="45720" tIns="27432" rIns="45720" bIns="27432" anchor="t">
             <a:spAutoFit/>
           </a:bodyPr>
           <a:lstStyle/>
@@ -19797,14 +20222,182 @@
               </a:lnSpc>
             </a:pPr>
             <a:r>
-              <a:rPr sz="1100" b="0" i="0">
+              <a:rPr sz="1100" b="0" i="0" dirty="0" err="1">
                 <a:solidFill>
                   <a:srgbClr val="5B6675"/>
                 </a:solidFill>
                 <a:latin typeface="Calibri"/>
               </a:rPr>
-              <a:t>Рис. 6. Проверка на узле: имя, адрес, процесс-владелец соединения, хэш файла</a:t>
-            </a:r>
+              <a:t>Рис</a:t>
+            </a:r>
+            <a:r>
+              <a:rPr sz="1100" b="0" i="0" dirty="0">
+                <a:solidFill>
+                  <a:srgbClr val="5B6675"/>
+                </a:solidFill>
+                <a:latin typeface="Calibri"/>
+              </a:rPr>
+              <a:t>. 6. </a:t>
+            </a:r>
+            <a:r>
+              <a:rPr sz="1100" b="0" i="0" dirty="0" err="1">
+                <a:solidFill>
+                  <a:srgbClr val="5B6675"/>
+                </a:solidFill>
+                <a:latin typeface="Calibri"/>
+              </a:rPr>
+              <a:t>Проверка</a:t>
+            </a:r>
+            <a:r>
+              <a:rPr sz="1100" b="0" i="0" dirty="0">
+                <a:solidFill>
+                  <a:srgbClr val="5B6675"/>
+                </a:solidFill>
+                <a:latin typeface="Calibri"/>
+              </a:rPr>
+              <a:t> </a:t>
+            </a:r>
+            <a:r>
+              <a:rPr sz="1100" b="0" i="0" dirty="0" err="1">
+                <a:solidFill>
+                  <a:srgbClr val="5B6675"/>
+                </a:solidFill>
+                <a:latin typeface="Calibri"/>
+              </a:rPr>
+              <a:t>на</a:t>
+            </a:r>
+            <a:r>
+              <a:rPr sz="1100" b="0" i="0" dirty="0">
+                <a:solidFill>
+                  <a:srgbClr val="5B6675"/>
+                </a:solidFill>
+                <a:latin typeface="Calibri"/>
+              </a:rPr>
+              <a:t> </a:t>
+            </a:r>
+            <a:r>
+              <a:rPr sz="1100" b="0" i="0" dirty="0" err="1">
+                <a:solidFill>
+                  <a:srgbClr val="5B6675"/>
+                </a:solidFill>
+                <a:latin typeface="Calibri"/>
+              </a:rPr>
+              <a:t>узле</a:t>
+            </a:r>
+            <a:r>
+              <a:rPr sz="1100" b="0" i="0" dirty="0">
+                <a:solidFill>
+                  <a:srgbClr val="5B6675"/>
+                </a:solidFill>
+                <a:latin typeface="Calibri"/>
+              </a:rPr>
+              <a:t>: </a:t>
+            </a:r>
+            <a:r>
+              <a:rPr sz="1100" b="0" i="0" dirty="0" err="1">
+                <a:solidFill>
+                  <a:srgbClr val="5B6675"/>
+                </a:solidFill>
+                <a:latin typeface="Calibri"/>
+              </a:rPr>
+              <a:t>имя</a:t>
+            </a:r>
+            <a:r>
+              <a:rPr sz="1100" b="0" i="0" dirty="0">
+                <a:solidFill>
+                  <a:srgbClr val="5B6675"/>
+                </a:solidFill>
+                <a:latin typeface="Calibri"/>
+              </a:rPr>
+              <a:t>, </a:t>
+            </a:r>
+            <a:r>
+              <a:rPr sz="1100" b="0" i="0" dirty="0" err="1">
+                <a:solidFill>
+                  <a:srgbClr val="5B6675"/>
+                </a:solidFill>
+                <a:latin typeface="Calibri"/>
+              </a:rPr>
+              <a:t>адрес</a:t>
+            </a:r>
+            <a:r>
+              <a:rPr sz="1100" b="0" i="0" dirty="0">
+                <a:solidFill>
+                  <a:srgbClr val="5B6675"/>
+                </a:solidFill>
+                <a:latin typeface="Calibri"/>
+              </a:rPr>
+              <a:t>, </a:t>
+            </a:r>
+            <a:r>
+              <a:rPr sz="1100" b="0" i="0" dirty="0" err="1">
+                <a:solidFill>
+                  <a:srgbClr val="5B6675"/>
+                </a:solidFill>
+                <a:latin typeface="Calibri"/>
+              </a:rPr>
+              <a:t>процесс-владелец</a:t>
+            </a:r>
+            <a:r>
+              <a:rPr sz="1100" b="0" i="0" dirty="0">
+                <a:solidFill>
+                  <a:srgbClr val="5B6675"/>
+                </a:solidFill>
+                <a:latin typeface="Calibri"/>
+              </a:rPr>
+              <a:t> </a:t>
+            </a:r>
+            <a:r>
+              <a:rPr sz="1100" b="0" i="0" dirty="0" err="1">
+                <a:solidFill>
+                  <a:srgbClr val="5B6675"/>
+                </a:solidFill>
+                <a:latin typeface="Calibri"/>
+              </a:rPr>
+              <a:t>соединения</a:t>
+            </a:r>
+            <a:r>
+              <a:rPr sz="1100" b="0" i="0" dirty="0">
+                <a:solidFill>
+                  <a:srgbClr val="5B6675"/>
+                </a:solidFill>
+                <a:latin typeface="Calibri"/>
+              </a:rPr>
+              <a:t>, </a:t>
+            </a:r>
+            <a:r>
+              <a:rPr sz="1100" b="0" i="0" dirty="0" err="1">
+                <a:solidFill>
+                  <a:srgbClr val="5B6675"/>
+                </a:solidFill>
+                <a:latin typeface="Calibri"/>
+              </a:rPr>
+              <a:t>хэш</a:t>
+            </a:r>
+            <a:r>
+              <a:rPr sz="1100" b="0" i="0" dirty="0">
+                <a:solidFill>
+                  <a:srgbClr val="5B6675"/>
+                </a:solidFill>
+                <a:latin typeface="Calibri"/>
+              </a:rPr>
+              <a:t> </a:t>
+            </a:r>
+            <a:r>
+              <a:rPr sz="1100" b="0" i="0" dirty="0" err="1">
+                <a:solidFill>
+                  <a:srgbClr val="5B6675"/>
+                </a:solidFill>
+                <a:latin typeface="Calibri"/>
+              </a:rPr>
+              <a:t>файла</a:t>
+            </a:r>
+            <a:endParaRPr sz="1100" b="0" i="0" dirty="0">
+              <a:solidFill>
+                <a:srgbClr val="5B6675"/>
+              </a:solidFill>
+              <a:latin typeface="Calibri"/>
+            </a:endParaRPr>
           </a:p>
         </p:txBody>
       </p:sp>
@@ -19849,6 +20442,7 @@
           <a:lstStyle/>
           <a:p>
             <a:pPr algn="ctr"/>
+            <a:endParaRPr/>
           </a:p>
         </p:txBody>
       </p:sp>
@@ -19893,6 +20487,7 @@
           <a:lstStyle/>
           <a:p>
             <a:pPr algn="ctr"/>
+            <a:endParaRPr/>
           </a:p>
         </p:txBody>
       </p:sp>
@@ -19913,7 +20508,7 @@
           <a:noFill/>
         </p:spPr>
         <p:txBody>
-          <a:bodyPr wrap="square" anchor="t" lIns="45720" rIns="45720" tIns="27432" bIns="27432">
+          <a:bodyPr wrap="square" lIns="45720" tIns="27432" rIns="45720" bIns="27432" anchor="t">
             <a:spAutoFit/>
           </a:bodyPr>
           <a:lstStyle/>
@@ -19952,7 +20547,7 @@
           <a:noFill/>
         </p:spPr>
         <p:txBody>
-          <a:bodyPr wrap="square" anchor="t" lIns="45720" rIns="45720" tIns="27432" bIns="27432">
+          <a:bodyPr wrap="square" lIns="45720" tIns="27432" rIns="45720" bIns="27432" anchor="t">
             <a:spAutoFit/>
           </a:bodyPr>
           <a:lstStyle/>
@@ -20118,6 +20713,7 @@
           <a:lstStyle/>
           <a:p>
             <a:pPr algn="ctr"/>
+            <a:endParaRPr/>
           </a:p>
         </p:txBody>
       </p:sp>
@@ -20162,6 +20758,7 @@
           <a:lstStyle/>
           <a:p>
             <a:pPr algn="ctr"/>
+            <a:endParaRPr/>
           </a:p>
         </p:txBody>
       </p:sp>
@@ -20182,7 +20779,7 @@
           <a:noFill/>
         </p:spPr>
         <p:txBody>
-          <a:bodyPr wrap="square" anchor="t" lIns="45720" rIns="45720" tIns="27432" bIns="27432">
+          <a:bodyPr wrap="square" lIns="45720" tIns="27432" rIns="45720" bIns="27432" anchor="t">
             <a:spAutoFit/>
           </a:bodyPr>
           <a:lstStyle/>
@@ -20221,7 +20818,7 @@
           <a:noFill/>
         </p:spPr>
         <p:txBody>
-          <a:bodyPr wrap="square" anchor="t" lIns="45720" rIns="45720" tIns="27432" bIns="27432">
+          <a:bodyPr wrap="square" lIns="45720" tIns="27432" rIns="45720" bIns="27432" anchor="t">
             <a:spAutoFit/>
           </a:bodyPr>
           <a:lstStyle/>
@@ -20328,7 +20925,7 @@
           <a:noFill/>
         </p:spPr>
         <p:txBody>
-          <a:bodyPr wrap="square" anchor="t" lIns="45720" rIns="45720" tIns="27432" bIns="27432">
+          <a:bodyPr wrap="square" lIns="45720" tIns="27432" rIns="45720" bIns="27432" anchor="t">
             <a:spAutoFit/>
           </a:bodyPr>
           <a:lstStyle/>
@@ -20367,7 +20964,7 @@
           <a:noFill/>
         </p:spPr>
         <p:txBody>
-          <a:bodyPr wrap="square" anchor="t" lIns="45720" rIns="45720" tIns="27432" bIns="27432">
+          <a:bodyPr wrap="square" lIns="45720" tIns="27432" rIns="45720" bIns="27432" anchor="t">
             <a:spAutoFit/>
           </a:bodyPr>
           <a:lstStyle/>

</xml_diff>